<commit_message>
Docs updated with corrected kernel results and coexistence
</commit_message>
<xml_diff>
--- a/docs/RUDP_Host_Guide.pptx
+++ b/docs/RUDP_Host_Guide.pptx
@@ -22695,7 +22695,7 @@
                 <a:ea typeface="Calibri" pitchFamily="34" charset="-122"/>
                 <a:cs typeface="Calibri" pitchFamily="34" charset="-120"/>
               </a:rPr>
-              <a:t>Against tuned AIMD the neural agent is 61 percent faster on the lossy path, 70 percent on the 5G-like path and 83 percent on the satellite path. All three are highly significant. On the reordering path it is 33 percent faster but that is not significant.</a:t>
+              <a:t>Against tuned AIMD the neural agent is 71 percent faster on the lossy path, 65 percent on the 5G-like path and 83 percent on the satellite path, all significant. On the reordering path it is 60 percent faster but that is not significant.</a:t>
             </a:r>
             <a:endParaRPr lang="en-US" sz="1400" dirty="0"/>
           </a:p>
@@ -22716,7 +22716,7 @@
                 <a:ea typeface="Calibri" pitchFamily="34" charset="-122"/>
                 <a:cs typeface="Calibri" pitchFamily="34" charset="-120"/>
               </a:rPr>
-              <a:t>Kernel TCP is still faster than our agent on every path, between one and a half and three times. We are not claiming to beat TCP.</a:t>
+              <a:t>Kernel TCP is still faster than our agent on every path, by one and a half to one and seven tenths. We are not claiming to beat TCP.</a:t>
             </a:r>
             <a:endParaRPr lang="en-US" sz="1400" dirty="0"/>
           </a:p>
@@ -22737,7 +22737,28 @@
                 <a:ea typeface="Calibri" pitchFamily="34" charset="-122"/>
                 <a:cs typeface="Calibri" pitchFamily="34" charset="-120"/>
               </a:rPr>
-              <a:t>Our first three runs were wrong: the netem queue limit counted packets in flight, our baseline was untuned, and TCP sent bigger payloads. We found that, fixed it and re-ran everything.</a:t>
+              <a:t>We also put a kernel TCP flow and one RUDP flow on the same link. The neural agent takes 24 to 34 percent of it, so it does not starve TCP; tuned AIMD gets only 5 to 17 percent.</a:t>
+            </a:r>
+            <a:endParaRPr lang="en-US" sz="1400" dirty="0"/>
+          </a:p>
+          <a:p>
+            <a:pPr marL="342900" indent="-342900">
+              <a:spcAft>
+                <a:spcPts val="600"/>
+              </a:spcAft>
+              <a:buSzPct val="100000"/>
+              <a:buChar char="•"/>
+            </a:pPr>
+            <a:r>
+              <a:rPr lang="en-US" sz="1400" dirty="0">
+                <a:solidFill>
+                  <a:srgbClr val="1B2430"/>
+                </a:solidFill>
+                <a:latin typeface="Calibri" pitchFamily="34" charset="0"/>
+                <a:ea typeface="Calibri" pitchFamily="34" charset="-122"/>
+                <a:cs typeface="Calibri" pitchFamily="34" charset="-120"/>
+              </a:rPr>
+              <a:t>Our first runs were wrong four times: the netem queue limit counted packets in flight, the baseline was untuned, the payload sizes differed, and finally RUDP was sending 40-byte synthetic packets. We found each one, fixed it, re-ran everything and documented it.</a:t>
             </a:r>
             <a:endParaRPr lang="en-US" sz="1400" dirty="0"/>
           </a:p>
@@ -22815,7 +22836,7 @@
                 <a:ea typeface="Calibri" pitchFamily="34" charset="-122"/>
                 <a:cs typeface="Calibri" pitchFamily="34" charset="-120"/>
               </a:rPr>
-              <a:t>Q: Does it beat TCP? A: No. It beats our AIMD baselines on a real kernel path; mature kernel TCP is faster, by 1.5x to 3.2x. Q: Why were the first runs wrong? A: netem's limit also counts packets in the delay line, so a large window overflowed it on the satellite path.</a:t>
+              <a:t>Q: Does it beat TCP? A: No. It beats our AIMD baselines on a real kernel path; mature kernel TCP is faster, by 1.5x to 1.7x. Q: Does it starve TCP? A: No, it takes 24 to 34 percent of a shared link (3 runs per cell, one laptop). Q: Why were the first runs wrong? A: four separate mistakes, the last being 40-byte synthetic packets against 512-byte TCP payloads; all fixed and re-run.</a:t>
             </a:r>
             <a:endParaRPr lang="en-US" sz="1400" dirty="0"/>
           </a:p>
@@ -23629,7 +23650,7 @@
                 <a:ea typeface="Calibri" pitchFamily="34" charset="-122"/>
                 <a:cs typeface="Calibri" pitchFamily="34" charset="-120"/>
               </a:rPr>
-              <a:t>The kernel TCP coexistence measurement is written but not yet run.</a:t>
+              <a:t>Kernel TCP coexistence is measured: the neural agent takes 24 to 34 percent of a shared link, so it does not starve TCP, with only three runs per cell.</a:t>
             </a:r>
             <a:endParaRPr lang="en-US" sz="1400" dirty="0"/>
           </a:p>
@@ -23707,7 +23728,7 @@
                 <a:ea typeface="Calibri" pitchFamily="34" charset="-122"/>
                 <a:cs typeface="Calibri" pitchFamily="34" charset="-120"/>
               </a:rPr>
-              <a:t>Did you test against kernel TCP? The script is written but the measurement still has to be run on a Linux host with tc.</a:t>
+              <a:t>Did you test against kernel TCP? Yes, on kernel netem: the neural agent took 24 to 34 percent of a shared link, three runs per cell on one laptop.</a:t>
             </a:r>
             <a:endParaRPr lang="en-US" sz="1400" dirty="0"/>
           </a:p>
@@ -25787,7 +25808,7 @@
                 <a:ea typeface="Calibri" pitchFamily="34" charset="-122"/>
                 <a:cs typeface="Calibri" pitchFamily="34" charset="-120"/>
               </a:rPr>
-              <a:t>Yes. Delay, loss and jitter are emulated in our client, in a separate proxy on real UDP sockets, and in virtual time; these agree with each other. We also ran it once on the Linux kernel with tc netem on one laptop: the agent beat tuned AIMD there, but kernel TCP was 1.5 to 3.2 times faster than us. No multi-machine path was tested.</a:t>
+              <a:t>Yes. Delay, loss and jitter are emulated in our client, in a separate proxy on real UDP sockets, and in virtual time; these agree with each other. We also ran it once on the Linux kernel with tc netem on one laptop: the agent beat tuned AIMD there, but kernel TCP was 1.5 to 1.7 times faster than us. No multi-machine path was tested.</a:t>
             </a:r>
             <a:endParaRPr lang="en-US" sz="1350" dirty="0"/>
           </a:p>
@@ -26597,7 +26618,7 @@
                 <a:ea typeface="Calibri" pitchFamily="34" charset="-122"/>
                 <a:cs typeface="Calibri" pitchFamily="34" charset="-120"/>
               </a:rPr>
-              <a:t>No, not entirely: against tuned AIMD it takes 68 percent of a shared link, (CUBIC takes 61 percent). Nothing starves. We did not train for fairness. With unequal round-trip times two neural flows are fairer than two AIMD flows (Jain 0.84 against 0.64 at +150 ms). The test against kernel TCP is written but not yet run.</a:t>
+              <a:t>No, not entirely: against tuned AIMD it takes 68 percent of a shared link, (CUBIC takes 61 percent). Nothing starves. We did not train for fairness. With unequal round-trip times two neural flows are fairer than two AIMD flows (Jain 0.84 against 0.64 at +150 ms). Against a kernel TCP flow on the same link it takes only 24 to 34 percent, so it does not starve TCP (three runs per cell).</a:t>
             </a:r>
             <a:endParaRPr lang="en-US" sz="1350" dirty="0"/>
           </a:p>

</xml_diff>

<commit_message>
Deck: add 'How it was tested' slide (39 slides); refresh host guide
</commit_message>
<xml_diff>
--- a/docs/RUDP_Host_Guide.pptx
+++ b/docs/RUDP_Host_Guide.pptx
@@ -47,9 +47,11 @@
     <p:sldId id="295" r:id="rId41"/>
     <p:sldId id="296" r:id="rId42"/>
     <p:sldId id="297" r:id="rId43"/>
+    <p:sldId id="298" r:id="rId44"/>
+    <p:sldId id="299" r:id="rId45"/>
   </p:sldIdLst>
   <p:notesMasterIdLst>
-    <p:notesMasterId r:id="rId44"/>
+    <p:notesMasterId r:id="rId46"/>
   </p:notesMasterIdLst>
   <p:sldSz cx="12192000" cy="6858000"/>
   <p:notesSz cx="6858000" cy="12192000"/>
@@ -3735,6 +3737,182 @@
             <a:fld id="{F7021451-1387-4CA6-816F-3879F97B5CBC}" type="slidenum">
               <a:rPr lang="en-US"/>
               <a:t>42</a:t>
+            </a:fld>
+            <a:endParaRPr lang="en-US"/>
+          </a:p>
+        </p:txBody>
+      </p:sp>
+    </p:spTree>
+    <p:extLst>
+      <p:ext uri="{BB962C8B-B14F-4D97-AF65-F5344CB8AC3E}">
+        <p14:creationId xmlns:p14="http://schemas.microsoft.com/office/powerpoint/2010/main" val="1024086991"/>
+      </p:ext>
+    </p:extLst>
+  </p:cSld>
+  <p:clrMapOvr>
+    <a:masterClrMapping/>
+  </p:clrMapOvr>
+</p:notes>
+</file>
+
+<file path=ppt/notesSlides/notesSlide43.xml><?xml version="1.0" encoding="utf-8"?>
+<p:notes xmlns:a="http://schemas.openxmlformats.org/drawingml/2006/main" xmlns:r="http://schemas.openxmlformats.org/officeDocument/2006/relationships" xmlns:p="http://schemas.openxmlformats.org/presentationml/2006/main">
+  <p:cSld>
+    <p:spTree>
+      <p:nvGrpSpPr>
+        <p:cNvPr id="1" name=""/>
+        <p:cNvGrpSpPr/>
+        <p:nvPr/>
+      </p:nvGrpSpPr>
+      <p:grpSpPr>
+        <a:xfrm>
+          <a:off x="0" y="0"/>
+          <a:ext cx="0" cy="0"/>
+          <a:chOff x="0" y="0"/>
+          <a:chExt cx="0" cy="0"/>
+        </a:xfrm>
+      </p:grpSpPr>
+      <p:sp>
+        <p:nvSpPr>
+          <p:cNvPr id="2" name="Slide Image Placeholder 1"/>
+          <p:cNvSpPr>
+            <a:spLocks noGrp="1" noRot="1" noChangeAspect="1"/>
+          </p:cNvSpPr>
+          <p:nvPr>
+            <p:ph type="sldImg"/>
+          </p:nvPr>
+        </p:nvSpPr>
+        <p:spPr/>
+      </p:sp>
+      <p:sp>
+        <p:nvSpPr>
+          <p:cNvPr id="3" name="Notes Placeholder 2"/>
+          <p:cNvSpPr>
+            <a:spLocks noGrp="1"/>
+          </p:cNvSpPr>
+          <p:nvPr>
+            <p:ph type="body" idx="1"/>
+          </p:nvPr>
+        </p:nvSpPr>
+        <p:spPr/>
+        <p:txBody>
+          <a:bodyPr/>
+          <a:lstStyle/>
+          <a:p>
+            <a:r>
+              <a:rPr lang="en-US" dirty="0"/>
+              <a:t/>
+            </a:r>
+            <a:endParaRPr lang="en-US" dirty="0"/>
+          </a:p>
+        </p:txBody>
+      </p:sp>
+      <p:sp>
+        <p:nvSpPr>
+          <p:cNvPr id="4" name="Slide Number Placeholder 3"/>
+          <p:cNvSpPr>
+            <a:spLocks noGrp="1"/>
+          </p:cNvSpPr>
+          <p:nvPr>
+            <p:ph type="sldNum" sz="quarter" idx="10"/>
+          </p:nvPr>
+        </p:nvSpPr>
+        <p:spPr/>
+        <p:txBody>
+          <a:bodyPr/>
+          <a:lstStyle/>
+          <a:p>
+            <a:fld id="{F7021451-1387-4CA6-816F-3879F97B5CBC}" type="slidenum">
+              <a:rPr lang="en-US"/>
+              <a:t>43</a:t>
+            </a:fld>
+            <a:endParaRPr lang="en-US"/>
+          </a:p>
+        </p:txBody>
+      </p:sp>
+    </p:spTree>
+    <p:extLst>
+      <p:ext uri="{BB962C8B-B14F-4D97-AF65-F5344CB8AC3E}">
+        <p14:creationId xmlns:p14="http://schemas.microsoft.com/office/powerpoint/2010/main" val="1024086991"/>
+      </p:ext>
+    </p:extLst>
+  </p:cSld>
+  <p:clrMapOvr>
+    <a:masterClrMapping/>
+  </p:clrMapOvr>
+</p:notes>
+</file>
+
+<file path=ppt/notesSlides/notesSlide44.xml><?xml version="1.0" encoding="utf-8"?>
+<p:notes xmlns:a="http://schemas.openxmlformats.org/drawingml/2006/main" xmlns:r="http://schemas.openxmlformats.org/officeDocument/2006/relationships" xmlns:p="http://schemas.openxmlformats.org/presentationml/2006/main">
+  <p:cSld>
+    <p:spTree>
+      <p:nvGrpSpPr>
+        <p:cNvPr id="1" name=""/>
+        <p:cNvGrpSpPr/>
+        <p:nvPr/>
+      </p:nvGrpSpPr>
+      <p:grpSpPr>
+        <a:xfrm>
+          <a:off x="0" y="0"/>
+          <a:ext cx="0" cy="0"/>
+          <a:chOff x="0" y="0"/>
+          <a:chExt cx="0" cy="0"/>
+        </a:xfrm>
+      </p:grpSpPr>
+      <p:sp>
+        <p:nvSpPr>
+          <p:cNvPr id="2" name="Slide Image Placeholder 1"/>
+          <p:cNvSpPr>
+            <a:spLocks noGrp="1" noRot="1" noChangeAspect="1"/>
+          </p:cNvSpPr>
+          <p:nvPr>
+            <p:ph type="sldImg"/>
+          </p:nvPr>
+        </p:nvSpPr>
+        <p:spPr/>
+      </p:sp>
+      <p:sp>
+        <p:nvSpPr>
+          <p:cNvPr id="3" name="Notes Placeholder 2"/>
+          <p:cNvSpPr>
+            <a:spLocks noGrp="1"/>
+          </p:cNvSpPr>
+          <p:nvPr>
+            <p:ph type="body" idx="1"/>
+          </p:nvPr>
+        </p:nvSpPr>
+        <p:spPr/>
+        <p:txBody>
+          <a:bodyPr/>
+          <a:lstStyle/>
+          <a:p>
+            <a:r>
+              <a:rPr lang="en-US" dirty="0"/>
+              <a:t/>
+            </a:r>
+            <a:endParaRPr lang="en-US" dirty="0"/>
+          </a:p>
+        </p:txBody>
+      </p:sp>
+      <p:sp>
+        <p:nvSpPr>
+          <p:cNvPr id="4" name="Slide Number Placeholder 3"/>
+          <p:cNvSpPr>
+            <a:spLocks noGrp="1"/>
+          </p:cNvSpPr>
+          <p:nvPr>
+            <p:ph type="sldNum" sz="quarter" idx="10"/>
+          </p:nvPr>
+        </p:nvSpPr>
+        <p:spPr/>
+        <p:txBody>
+          <a:bodyPr/>
+          <a:lstStyle/>
+          <a:p>
+            <a:fld id="{F7021451-1387-4CA6-816F-3879F97B5CBC}" type="slidenum">
+              <a:rPr lang="en-US"/>
+              <a:t>44</a:t>
             </a:fld>
             <a:endParaRPr lang="en-US"/>
           </a:p>
@@ -9301,7 +9479,7 @@
                           <a:ea typeface="Calibri" pitchFamily="34" charset="-122"/>
                           <a:cs typeface="Calibri" pitchFamily="34" charset="-120"/>
                         </a:rPr>
-                        <a:t>20</a:t>
+                        <a:t>21</a:t>
                       </a:r>
                       <a:endParaRPr lang="en-US" sz="1200" dirty="0">
                         <a:latin typeface="Calibri" charset="0"/>
@@ -9366,7 +9544,7 @@
                           <a:ea typeface="Calibri" pitchFamily="34" charset="-122"/>
                           <a:cs typeface="Calibri" pitchFamily="34" charset="-120"/>
                         </a:rPr>
-                        <a:t>RUDP Chat demo</a:t>
+                        <a:t>More evidence: baselines, SACK, reordering</a:t>
                       </a:r>
                       <a:endParaRPr lang="en-US" sz="1200" dirty="0">
                         <a:latin typeface="Calibri" charset="0"/>
@@ -9693,7 +9871,7 @@
                           <a:ea typeface="Calibri" pitchFamily="34" charset="-122"/>
                           <a:cs typeface="Calibri" pitchFamily="34" charset="-120"/>
                         </a:rPr>
-                        <a:t>21</a:t>
+                        <a:t>22</a:t>
                       </a:r>
                       <a:endParaRPr lang="en-US" sz="1200" dirty="0">
                         <a:latin typeface="Calibri" charset="0"/>
@@ -9758,7 +9936,7 @@
                           <a:ea typeface="Calibri" pitchFamily="34" charset="-122"/>
                           <a:cs typeface="Calibri" pitchFamily="34" charset="-120"/>
                         </a:rPr>
-                        <a:t>More evidence: baselines, SACK, reordering</a:t>
+                        <a:t>Neural agent in the C transport</a:t>
                       </a:r>
                       <a:endParaRPr lang="en-US" sz="1200" dirty="0">
                         <a:latin typeface="Calibri" charset="0"/>
@@ -10085,7 +10263,7 @@
                           <a:ea typeface="Calibri" pitchFamily="34" charset="-122"/>
                           <a:cs typeface="Calibri" pitchFamily="34" charset="-120"/>
                         </a:rPr>
-                        <a:t>22</a:t>
+                        <a:t>23</a:t>
                       </a:r>
                       <a:endParaRPr lang="en-US" sz="1200" dirty="0">
                         <a:latin typeface="Calibri" charset="0"/>
@@ -10150,7 +10328,7 @@
                           <a:ea typeface="Calibri" pitchFamily="34" charset="-122"/>
                           <a:cs typeface="Calibri" pitchFamily="34" charset="-120"/>
                         </a:rPr>
-                        <a:t>Neural agent in the C transport</a:t>
+                        <a:t>Fairness, ablations, chat fixes</a:t>
                       </a:r>
                       <a:endParaRPr lang="en-US" sz="1200" dirty="0">
                         <a:latin typeface="Calibri" charset="0"/>
@@ -10215,7 +10393,7 @@
                           <a:ea typeface="Calibri" pitchFamily="34" charset="-122"/>
                           <a:cs typeface="Calibri" pitchFamily="34" charset="-120"/>
                         </a:rPr>
-                        <a:t>1:00</a:t>
+                        <a:t>0:50</a:t>
                       </a:r>
                       <a:endParaRPr lang="en-US" sz="1200" dirty="0">
                         <a:latin typeface="Calibri" charset="0"/>
@@ -10477,7 +10655,7 @@
                           <a:ea typeface="Calibri" pitchFamily="34" charset="-122"/>
                           <a:cs typeface="Calibri" pitchFamily="34" charset="-120"/>
                         </a:rPr>
-                        <a:t>23</a:t>
+                        <a:t>24</a:t>
                       </a:r>
                       <a:endParaRPr lang="en-US" sz="1200" dirty="0">
                         <a:latin typeface="Calibri" charset="0"/>
@@ -10542,7 +10720,7 @@
                           <a:ea typeface="Calibri" pitchFamily="34" charset="-122"/>
                           <a:cs typeface="Calibri" pitchFamily="34" charset="-120"/>
                         </a:rPr>
-                        <a:t>Fairness, ablations, chat fixes</a:t>
+                        <a:t>Safety net: hand over to AIMD</a:t>
                       </a:r>
                       <a:endParaRPr lang="en-US" sz="1200" dirty="0">
                         <a:latin typeface="Calibri" charset="0"/>
@@ -10869,7 +11047,7 @@
                           <a:ea typeface="Calibri" pitchFamily="34" charset="-122"/>
                           <a:cs typeface="Calibri" pitchFamily="34" charset="-120"/>
                         </a:rPr>
-                        <a:t>24</a:t>
+                        <a:t>25</a:t>
                       </a:r>
                       <a:endParaRPr lang="en-US" sz="1200" dirty="0">
                         <a:latin typeface="Calibri" charset="0"/>
@@ -10934,7 +11112,7 @@
                           <a:ea typeface="Calibri" pitchFamily="34" charset="-122"/>
                           <a:cs typeface="Calibri" pitchFamily="34" charset="-120"/>
                         </a:rPr>
-                        <a:t>Safety net: hand over to AIMD</a:t>
+                        <a:t>Selective Repeat is now the default</a:t>
                       </a:r>
                       <a:endParaRPr lang="en-US" sz="1200" dirty="0">
                         <a:latin typeface="Calibri" charset="0"/>
@@ -11261,7 +11439,7 @@
                           <a:ea typeface="Calibri" pitchFamily="34" charset="-122"/>
                           <a:cs typeface="Calibri" pitchFamily="34" charset="-120"/>
                         </a:rPr>
-                        <a:t>25</a:t>
+                        <a:t>26</a:t>
                       </a:r>
                       <a:endParaRPr lang="en-US" sz="1200" dirty="0">
                         <a:latin typeface="Calibri" charset="0"/>
@@ -11326,7 +11504,7 @@
                           <a:ea typeface="Calibri" pitchFamily="34" charset="-122"/>
                           <a:cs typeface="Calibri" pitchFamily="34" charset="-120"/>
                         </a:rPr>
-                        <a:t>Selective Repeat is now the default</a:t>
+                        <a:t>Final results: tuned baselines, real clock</a:t>
                       </a:r>
                       <a:endParaRPr lang="en-US" sz="1200" dirty="0">
                         <a:latin typeface="Calibri" charset="0"/>
@@ -11391,7 +11569,7 @@
                           <a:ea typeface="Calibri" pitchFamily="34" charset="-122"/>
                           <a:cs typeface="Calibri" pitchFamily="34" charset="-120"/>
                         </a:rPr>
-                        <a:t>0:50</a:t>
+                        <a:t>1:00</a:t>
                       </a:r>
                       <a:endParaRPr lang="en-US" sz="1200" dirty="0">
                         <a:latin typeface="Calibri" charset="0"/>
@@ -11653,7 +11831,7 @@
                           <a:ea typeface="Calibri" pitchFamily="34" charset="-122"/>
                           <a:cs typeface="Calibri" pitchFamily="34" charset="-120"/>
                         </a:rPr>
-                        <a:t>26</a:t>
+                        <a:t>27</a:t>
                       </a:r>
                       <a:endParaRPr lang="en-US" sz="1200" dirty="0">
                         <a:latin typeface="Calibri" charset="0"/>
@@ -11718,7 +11896,7 @@
                           <a:ea typeface="Calibri" pitchFamily="34" charset="-122"/>
                           <a:cs typeface="Calibri" pitchFamily="34" charset="-120"/>
                         </a:rPr>
-                        <a:t>Final results: tuned baselines, real clock</a:t>
+                        <a:t>Real sockets found what the emulator could not</a:t>
                       </a:r>
                       <a:endParaRPr lang="en-US" sz="1200" dirty="0">
                         <a:latin typeface="Calibri" charset="0"/>
@@ -11783,7 +11961,7 @@
                           <a:ea typeface="Calibri" pitchFamily="34" charset="-122"/>
                           <a:cs typeface="Calibri" pitchFamily="34" charset="-120"/>
                         </a:rPr>
-                        <a:t>1:00</a:t>
+                        <a:t>0:50</a:t>
                       </a:r>
                       <a:endParaRPr lang="en-US" sz="1200" dirty="0">
                         <a:latin typeface="Calibri" charset="0"/>
@@ -12045,7 +12223,7 @@
                           <a:ea typeface="Calibri" pitchFamily="34" charset="-122"/>
                           <a:cs typeface="Calibri" pitchFamily="34" charset="-120"/>
                         </a:rPr>
-                        <a:t>27</a:t>
+                        <a:t>28</a:t>
                       </a:r>
                       <a:endParaRPr lang="en-US" sz="1200" dirty="0">
                         <a:latin typeface="Calibri" charset="0"/>
@@ -12110,7 +12288,7 @@
                           <a:ea typeface="Calibri" pitchFamily="34" charset="-122"/>
                           <a:cs typeface="Calibri" pitchFamily="34" charset="-120"/>
                         </a:rPr>
-                        <a:t>Real sockets found what the emulator could not</a:t>
+                        <a:t>A fast, faithful C simulator, and what it showed</a:t>
                       </a:r>
                       <a:endParaRPr lang="en-US" sz="1200" dirty="0">
                         <a:latin typeface="Calibri" charset="0"/>
@@ -12175,7 +12353,7 @@
                           <a:ea typeface="Calibri" pitchFamily="34" charset="-122"/>
                           <a:cs typeface="Calibri" pitchFamily="34" charset="-120"/>
                         </a:rPr>
-                        <a:t>0:50</a:t>
+                        <a:t>1:00</a:t>
                       </a:r>
                       <a:endParaRPr lang="en-US" sz="1200" dirty="0">
                         <a:latin typeface="Calibri" charset="0"/>
@@ -12437,7 +12615,7 @@
                           <a:ea typeface="Calibri" pitchFamily="34" charset="-122"/>
                           <a:cs typeface="Calibri" pitchFamily="34" charset="-120"/>
                         </a:rPr>
-                        <a:t>28</a:t>
+                        <a:t>29</a:t>
                       </a:r>
                       <a:endParaRPr lang="en-US" sz="1200" dirty="0">
                         <a:latin typeface="Calibri" charset="0"/>
@@ -12502,7 +12680,7 @@
                           <a:ea typeface="Calibri" pitchFamily="34" charset="-122"/>
                           <a:cs typeface="Calibri" pitchFamily="34" charset="-120"/>
                         </a:rPr>
-                        <a:t>A fast, faithful C simulator, and what it showed</a:t>
+                        <a:t>Fairness and file transfer</a:t>
                       </a:r>
                       <a:endParaRPr lang="en-US" sz="1200" dirty="0">
                         <a:latin typeface="Calibri" charset="0"/>
@@ -12567,7 +12745,7 @@
                           <a:ea typeface="Calibri" pitchFamily="34" charset="-122"/>
                           <a:cs typeface="Calibri" pitchFamily="34" charset="-120"/>
                         </a:rPr>
-                        <a:t>1:00</a:t>
+                        <a:t>0:50</a:t>
                       </a:r>
                       <a:endParaRPr lang="en-US" sz="1200" dirty="0">
                         <a:latin typeface="Calibri" charset="0"/>
@@ -12829,7 +13007,7 @@
                           <a:ea typeface="Calibri" pitchFamily="34" charset="-122"/>
                           <a:cs typeface="Calibri" pitchFamily="34" charset="-120"/>
                         </a:rPr>
-                        <a:t>29</a:t>
+                        <a:t>30</a:t>
                       </a:r>
                       <a:endParaRPr lang="en-US" sz="1200" dirty="0">
                         <a:latin typeface="Calibri" charset="0"/>
@@ -12894,7 +13072,7 @@
                           <a:ea typeface="Calibri" pitchFamily="34" charset="-122"/>
                           <a:cs typeface="Calibri" pitchFamily="34" charset="-120"/>
                         </a:rPr>
-                        <a:t>Fairness and file transfer</a:t>
+                        <a:t>Seeing the difference: the window</a:t>
                       </a:r>
                       <a:endParaRPr lang="en-US" sz="1200" dirty="0">
                         <a:latin typeface="Calibri" charset="0"/>
@@ -12959,7 +13137,7 @@
                           <a:ea typeface="Calibri" pitchFamily="34" charset="-122"/>
                           <a:cs typeface="Calibri" pitchFamily="34" charset="-120"/>
                         </a:rPr>
-                        <a:t>0:50</a:t>
+                        <a:t>0:40</a:t>
                       </a:r>
                       <a:endParaRPr lang="en-US" sz="1200" dirty="0">
                         <a:latin typeface="Calibri" charset="0"/>
@@ -13221,7 +13399,7 @@
                           <a:ea typeface="Calibri" pitchFamily="34" charset="-122"/>
                           <a:cs typeface="Calibri" pitchFamily="34" charset="-120"/>
                         </a:rPr>
-                        <a:t>30</a:t>
+                        <a:t>31</a:t>
                       </a:r>
                       <a:endParaRPr lang="en-US" sz="1200" dirty="0">
                         <a:latin typeface="Calibri" charset="0"/>
@@ -13286,7 +13464,7 @@
                           <a:ea typeface="Calibri" pitchFamily="34" charset="-122"/>
                           <a:cs typeface="Calibri" pitchFamily="34" charset="-120"/>
                         </a:rPr>
-                        <a:t>Seeing the difference: the window</a:t>
+                        <a:t>Closing gaps: fairness and cross traffic</a:t>
                       </a:r>
                       <a:endParaRPr lang="en-US" sz="1200" dirty="0">
                         <a:latin typeface="Calibri" charset="0"/>
@@ -13351,7 +13529,7 @@
                           <a:ea typeface="Calibri" pitchFamily="34" charset="-122"/>
                           <a:cs typeface="Calibri" pitchFamily="34" charset="-120"/>
                         </a:rPr>
-                        <a:t>0:40</a:t>
+                        <a:t>0:50</a:t>
                       </a:r>
                       <a:endParaRPr lang="en-US" sz="1200" dirty="0">
                         <a:latin typeface="Calibri" charset="0"/>
@@ -13613,7 +13791,7 @@
                           <a:ea typeface="Calibri" pitchFamily="34" charset="-122"/>
                           <a:cs typeface="Calibri" pitchFamily="34" charset="-120"/>
                         </a:rPr>
-                        <a:t>31</a:t>
+                        <a:t>32</a:t>
                       </a:r>
                       <a:endParaRPr lang="en-US" sz="1200" dirty="0">
                         <a:latin typeface="Calibri" charset="0"/>
@@ -13678,7 +13856,7 @@
                           <a:ea typeface="Calibri" pitchFamily="34" charset="-122"/>
                           <a:cs typeface="Calibri" pitchFamily="34" charset="-120"/>
                         </a:rPr>
-                        <a:t>Closing gaps: fairness and cross traffic</a:t>
+                        <a:t>How it was tested</a:t>
                       </a:r>
                       <a:endParaRPr lang="en-US" sz="1200" dirty="0">
                         <a:latin typeface="Calibri" charset="0"/>
@@ -13743,7 +13921,7 @@
                           <a:ea typeface="Calibri" pitchFamily="34" charset="-122"/>
                           <a:cs typeface="Calibri" pitchFamily="34" charset="-120"/>
                         </a:rPr>
-                        <a:t>0:50</a:t>
+                        <a:t>0:40</a:t>
                       </a:r>
                       <a:endParaRPr lang="en-US" sz="1200" dirty="0">
                         <a:latin typeface="Calibri" charset="0"/>
@@ -14005,7 +14183,7 @@
                           <a:ea typeface="Calibri" pitchFamily="34" charset="-122"/>
                           <a:cs typeface="Calibri" pitchFamily="34" charset="-120"/>
                         </a:rPr>
-                        <a:t>32</a:t>
+                        <a:t>33</a:t>
                       </a:r>
                       <a:endParaRPr lang="en-US" sz="1200" dirty="0">
                         <a:latin typeface="Calibri" charset="0"/>
@@ -14397,7 +14575,7 @@
                           <a:ea typeface="Calibri" pitchFamily="34" charset="-122"/>
                           <a:cs typeface="Calibri" pitchFamily="34" charset="-120"/>
                         </a:rPr>
-                        <a:t>33</a:t>
+                        <a:t>34</a:t>
                       </a:r>
                       <a:endParaRPr lang="en-US" sz="1200" dirty="0">
                         <a:latin typeface="Calibri" charset="0"/>
@@ -14789,7 +14967,7 @@
                           <a:ea typeface="Calibri" pitchFamily="34" charset="-122"/>
                           <a:cs typeface="Calibri" pitchFamily="34" charset="-120"/>
                         </a:rPr>
-                        <a:t>34</a:t>
+                        <a:t>35</a:t>
                       </a:r>
                       <a:endParaRPr lang="en-US" sz="1200" dirty="0">
                         <a:latin typeface="Calibri" charset="0"/>
@@ -15181,7 +15359,7 @@
                           <a:ea typeface="Calibri" pitchFamily="34" charset="-122"/>
                           <a:cs typeface="Calibri" pitchFamily="34" charset="-120"/>
                         </a:rPr>
-                        <a:t>35</a:t>
+                        <a:t>36</a:t>
                       </a:r>
                       <a:endParaRPr lang="en-US" sz="1200" dirty="0">
                         <a:latin typeface="Calibri" charset="0"/>
@@ -15246,7 +15424,7 @@
                           <a:ea typeface="Calibri" pitchFamily="34" charset="-122"/>
                           <a:cs typeface="Calibri" pitchFamily="34" charset="-120"/>
                         </a:rPr>
-                        <a:t>Learnings and future work</a:t>
+                        <a:t>First run between two machines</a:t>
                       </a:r>
                       <a:endParaRPr lang="en-US" sz="1200" dirty="0">
                         <a:latin typeface="Calibri" charset="0"/>
@@ -15311,7 +15489,7 @@
                           <a:ea typeface="Calibri" pitchFamily="34" charset="-122"/>
                           <a:cs typeface="Calibri" pitchFamily="34" charset="-120"/>
                         </a:rPr>
-                        <a:t>0:50</a:t>
+                        <a:t>0:45</a:t>
                       </a:r>
                       <a:endParaRPr lang="en-US" sz="1200" dirty="0">
                         <a:latin typeface="Calibri" charset="0"/>
@@ -15573,7 +15751,7 @@
                           <a:ea typeface="Calibri" pitchFamily="34" charset="-122"/>
                           <a:cs typeface="Calibri" pitchFamily="34" charset="-120"/>
                         </a:rPr>
-                        <a:t>36</a:t>
+                        <a:t>37</a:t>
                       </a:r>
                       <a:endParaRPr lang="en-US" sz="1200" dirty="0">
                         <a:latin typeface="Calibri" charset="0"/>
@@ -15638,7 +15816,7 @@
                           <a:ea typeface="Calibri" pitchFamily="34" charset="-122"/>
                           <a:cs typeface="Calibri" pitchFamily="34" charset="-120"/>
                         </a:rPr>
-                        <a:t>Thank you</a:t>
+                        <a:t>Learnings and future work</a:t>
                       </a:r>
                       <a:endParaRPr lang="en-US" sz="1200" dirty="0">
                         <a:latin typeface="Calibri" charset="0"/>
@@ -15703,7 +15881,7 @@
                           <a:ea typeface="Calibri" pitchFamily="34" charset="-122"/>
                           <a:cs typeface="Calibri" pitchFamily="34" charset="-120"/>
                         </a:rPr>
-                        <a:t>0:15</a:t>
+                        <a:t>0:50</a:t>
                       </a:r>
                       <a:endParaRPr lang="en-US" sz="1200" dirty="0">
                         <a:latin typeface="Calibri" charset="0"/>
@@ -15965,7 +16143,7 @@
                           <a:ea typeface="Calibri" pitchFamily="34" charset="-122"/>
                           <a:cs typeface="Calibri" pitchFamily="34" charset="-120"/>
                         </a:rPr>
-                        <a:t>37</a:t>
+                        <a:t>38</a:t>
                       </a:r>
                       <a:endParaRPr lang="en-US" sz="1200" dirty="0">
                         <a:latin typeface="Calibri" charset="0"/>
@@ -16030,7 +16208,7 @@
                           <a:ea typeface="Calibri" pitchFamily="34" charset="-122"/>
                           <a:cs typeface="Calibri" pitchFamily="34" charset="-120"/>
                         </a:rPr>
-                        <a:t>Appendix: slow start</a:t>
+                        <a:t>Thank you</a:t>
                       </a:r>
                       <a:endParaRPr lang="en-US" sz="1200" dirty="0">
                         <a:latin typeface="Calibri" charset="0"/>
@@ -16095,7 +16273,7 @@
                           <a:ea typeface="Calibri" pitchFamily="34" charset="-122"/>
                           <a:cs typeface="Calibri" pitchFamily="34" charset="-120"/>
                         </a:rPr>
-                        <a:t>-</a:t>
+                        <a:t>0:15</a:t>
                       </a:r>
                       <a:endParaRPr lang="en-US" sz="1200" dirty="0">
                         <a:latin typeface="Calibri" charset="0"/>
@@ -16348,6 +16526,398 @@
                       <a:pPr indent="0" marL="0">
                         <a:buNone/>
                       </a:pPr>
+                      <a:r>
+                        <a:rPr lang="en-US" sz="1200" dirty="0">
+                          <a:solidFill>
+                            <a:srgbClr val="1B2430"/>
+                          </a:solidFill>
+                          <a:latin typeface="Calibri" pitchFamily="34" charset="0"/>
+                          <a:ea typeface="Calibri" pitchFamily="34" charset="-122"/>
+                          <a:cs typeface="Calibri" pitchFamily="34" charset="-120"/>
+                        </a:rPr>
+                        <a:t>39</a:t>
+                      </a:r>
+                      <a:endParaRPr lang="en-US" sz="1200" dirty="0">
+                        <a:latin typeface="Calibri" charset="0"/>
+                        <a:ea typeface="Calibri" charset="0"/>
+                        <a:cs typeface="Calibri" charset="0"/>
+                      </a:endParaRPr>
+                    </a:p>
+                  </a:txBody>
+                  <a:tcPr marL="91440" marR="91440" marT="45720" marB="45720">
+                    <a:lnL w="6350" cap="flat" cmpd="sng" algn="ctr">
+                      <a:solidFill>
+                        <a:srgbClr val="D5DEE9"/>
+                      </a:solidFill>
+                      <a:prstDash val="solid"/>
+                      <a:round/>
+                      <a:headEnd type="none" w="med" len="med"/>
+                      <a:tailEnd type="none" w="med" len="med"/>
+                    </a:lnL>
+                    <a:lnR w="6350" cap="flat" cmpd="sng" algn="ctr">
+                      <a:solidFill>
+                        <a:srgbClr val="D5DEE9"/>
+                      </a:solidFill>
+                      <a:prstDash val="solid"/>
+                      <a:round/>
+                      <a:headEnd type="none" w="med" len="med"/>
+                      <a:tailEnd type="none" w="med" len="med"/>
+                    </a:lnR>
+                    <a:lnT w="6350" cap="flat" cmpd="sng" algn="ctr">
+                      <a:solidFill>
+                        <a:srgbClr val="D5DEE9"/>
+                      </a:solidFill>
+                      <a:prstDash val="solid"/>
+                      <a:round/>
+                      <a:headEnd type="none" w="med" len="med"/>
+                      <a:tailEnd type="none" w="med" len="med"/>
+                    </a:lnT>
+                    <a:lnB w="6350" cap="flat" cmpd="sng" algn="ctr">
+                      <a:solidFill>
+                        <a:srgbClr val="D5DEE9"/>
+                      </a:solidFill>
+                      <a:prstDash val="solid"/>
+                      <a:round/>
+                      <a:headEnd type="none" w="med" len="med"/>
+                      <a:tailEnd type="none" w="med" len="med"/>
+                    </a:lnB>
+                  </a:tcPr>
+                </a:tc>
+                <a:tc>
+                  <a:txBody>
+                    <a:bodyPr/>
+                    <a:lstStyle/>
+                    <a:p>
+                      <a:pPr indent="0" marL="0">
+                        <a:buNone/>
+                      </a:pPr>
+                      <a:r>
+                        <a:rPr lang="en-US" sz="1200" dirty="0">
+                          <a:solidFill>
+                            <a:srgbClr val="1B2430"/>
+                          </a:solidFill>
+                          <a:latin typeface="Calibri" pitchFamily="34" charset="0"/>
+                          <a:ea typeface="Calibri" pitchFamily="34" charset="-122"/>
+                          <a:cs typeface="Calibri" pitchFamily="34" charset="-120"/>
+                        </a:rPr>
+                        <a:t>Appendix: slow start</a:t>
+                      </a:r>
+                      <a:endParaRPr lang="en-US" sz="1200" dirty="0">
+                        <a:latin typeface="Calibri" charset="0"/>
+                        <a:ea typeface="Calibri" charset="0"/>
+                        <a:cs typeface="Calibri" charset="0"/>
+                      </a:endParaRPr>
+                    </a:p>
+                  </a:txBody>
+                  <a:tcPr marL="91440" marR="91440" marT="45720" marB="45720">
+                    <a:lnL w="6350" cap="flat" cmpd="sng" algn="ctr">
+                      <a:solidFill>
+                        <a:srgbClr val="D5DEE9"/>
+                      </a:solidFill>
+                      <a:prstDash val="solid"/>
+                      <a:round/>
+                      <a:headEnd type="none" w="med" len="med"/>
+                      <a:tailEnd type="none" w="med" len="med"/>
+                    </a:lnL>
+                    <a:lnR w="6350" cap="flat" cmpd="sng" algn="ctr">
+                      <a:solidFill>
+                        <a:srgbClr val="D5DEE9"/>
+                      </a:solidFill>
+                      <a:prstDash val="solid"/>
+                      <a:round/>
+                      <a:headEnd type="none" w="med" len="med"/>
+                      <a:tailEnd type="none" w="med" len="med"/>
+                    </a:lnR>
+                    <a:lnT w="6350" cap="flat" cmpd="sng" algn="ctr">
+                      <a:solidFill>
+                        <a:srgbClr val="D5DEE9"/>
+                      </a:solidFill>
+                      <a:prstDash val="solid"/>
+                      <a:round/>
+                      <a:headEnd type="none" w="med" len="med"/>
+                      <a:tailEnd type="none" w="med" len="med"/>
+                    </a:lnT>
+                    <a:lnB w="6350" cap="flat" cmpd="sng" algn="ctr">
+                      <a:solidFill>
+                        <a:srgbClr val="D5DEE9"/>
+                      </a:solidFill>
+                      <a:prstDash val="solid"/>
+                      <a:round/>
+                      <a:headEnd type="none" w="med" len="med"/>
+                      <a:tailEnd type="none" w="med" len="med"/>
+                    </a:lnB>
+                  </a:tcPr>
+                </a:tc>
+                <a:tc>
+                  <a:txBody>
+                    <a:bodyPr/>
+                    <a:lstStyle/>
+                    <a:p>
+                      <a:pPr indent="0" marL="0">
+                        <a:buNone/>
+                      </a:pPr>
+                      <a:r>
+                        <a:rPr lang="en-US" sz="1200" dirty="0">
+                          <a:solidFill>
+                            <a:srgbClr val="1B2430"/>
+                          </a:solidFill>
+                          <a:latin typeface="Calibri" pitchFamily="34" charset="0"/>
+                          <a:ea typeface="Calibri" pitchFamily="34" charset="-122"/>
+                          <a:cs typeface="Calibri" pitchFamily="34" charset="-120"/>
+                        </a:rPr>
+                        <a:t>-</a:t>
+                      </a:r>
+                      <a:endParaRPr lang="en-US" sz="1200" dirty="0">
+                        <a:latin typeface="Calibri" charset="0"/>
+                        <a:ea typeface="Calibri" charset="0"/>
+                        <a:cs typeface="Calibri" charset="0"/>
+                      </a:endParaRPr>
+                    </a:p>
+                  </a:txBody>
+                  <a:tcPr marL="91440" marR="91440" marT="45720" marB="45720">
+                    <a:lnL w="6350" cap="flat" cmpd="sng" algn="ctr">
+                      <a:solidFill>
+                        <a:srgbClr val="D5DEE9"/>
+                      </a:solidFill>
+                      <a:prstDash val="solid"/>
+                      <a:round/>
+                      <a:headEnd type="none" w="med" len="med"/>
+                      <a:tailEnd type="none" w="med" len="med"/>
+                    </a:lnL>
+                    <a:lnR w="6350" cap="flat" cmpd="sng" algn="ctr">
+                      <a:solidFill>
+                        <a:srgbClr val="D5DEE9"/>
+                      </a:solidFill>
+                      <a:prstDash val="solid"/>
+                      <a:round/>
+                      <a:headEnd type="none" w="med" len="med"/>
+                      <a:tailEnd type="none" w="med" len="med"/>
+                    </a:lnR>
+                    <a:lnT w="6350" cap="flat" cmpd="sng" algn="ctr">
+                      <a:solidFill>
+                        <a:srgbClr val="D5DEE9"/>
+                      </a:solidFill>
+                      <a:prstDash val="solid"/>
+                      <a:round/>
+                      <a:headEnd type="none" w="med" len="med"/>
+                      <a:tailEnd type="none" w="med" len="med"/>
+                    </a:lnT>
+                    <a:lnB w="6350" cap="flat" cmpd="sng" algn="ctr">
+                      <a:solidFill>
+                        <a:srgbClr val="D5DEE9"/>
+                      </a:solidFill>
+                      <a:prstDash val="solid"/>
+                      <a:round/>
+                      <a:headEnd type="none" w="med" len="med"/>
+                      <a:tailEnd type="none" w="med" len="med"/>
+                    </a:lnB>
+                  </a:tcPr>
+                </a:tc>
+              </a:tr>
+              <a:tr h="347472">
+                <a:tc>
+                  <a:txBody>
+                    <a:bodyPr/>
+                    <a:lstStyle/>
+                    <a:p>
+                      <a:pPr indent="0" marL="0">
+                        <a:buNone/>
+                      </a:pPr>
+                      <a:r>
+                        <a:rPr lang="en-US" sz="1200" dirty="0">
+                          <a:solidFill>
+                            <a:srgbClr val="1B2430"/>
+                          </a:solidFill>
+                          <a:latin typeface="Calibri" pitchFamily="34" charset="0"/>
+                          <a:ea typeface="Calibri" pitchFamily="34" charset="-122"/>
+                          <a:cs typeface="Calibri" pitchFamily="34" charset="-120"/>
+                        </a:rPr>
+                        <a:t>20</a:t>
+                      </a:r>
+                      <a:endParaRPr lang="en-US" sz="1200" dirty="0">
+                        <a:latin typeface="Calibri" charset="0"/>
+                        <a:ea typeface="Calibri" charset="0"/>
+                        <a:cs typeface="Calibri" charset="0"/>
+                      </a:endParaRPr>
+                    </a:p>
+                  </a:txBody>
+                  <a:tcPr marL="91440" marR="91440" marT="45720" marB="45720">
+                    <a:lnL w="6350" cap="flat" cmpd="sng" algn="ctr">
+                      <a:solidFill>
+                        <a:srgbClr val="D5DEE9"/>
+                      </a:solidFill>
+                      <a:prstDash val="solid"/>
+                      <a:round/>
+                      <a:headEnd type="none" w="med" len="med"/>
+                      <a:tailEnd type="none" w="med" len="med"/>
+                    </a:lnL>
+                    <a:lnR w="6350" cap="flat" cmpd="sng" algn="ctr">
+                      <a:solidFill>
+                        <a:srgbClr val="D5DEE9"/>
+                      </a:solidFill>
+                      <a:prstDash val="solid"/>
+                      <a:round/>
+                      <a:headEnd type="none" w="med" len="med"/>
+                      <a:tailEnd type="none" w="med" len="med"/>
+                    </a:lnR>
+                    <a:lnT w="6350" cap="flat" cmpd="sng" algn="ctr">
+                      <a:solidFill>
+                        <a:srgbClr val="D5DEE9"/>
+                      </a:solidFill>
+                      <a:prstDash val="solid"/>
+                      <a:round/>
+                      <a:headEnd type="none" w="med" len="med"/>
+                      <a:tailEnd type="none" w="med" len="med"/>
+                    </a:lnT>
+                    <a:lnB w="6350" cap="flat" cmpd="sng" algn="ctr">
+                      <a:solidFill>
+                        <a:srgbClr val="D5DEE9"/>
+                      </a:solidFill>
+                      <a:prstDash val="solid"/>
+                      <a:round/>
+                      <a:headEnd type="none" w="med" len="med"/>
+                      <a:tailEnd type="none" w="med" len="med"/>
+                    </a:lnB>
+                  </a:tcPr>
+                </a:tc>
+                <a:tc>
+                  <a:txBody>
+                    <a:bodyPr/>
+                    <a:lstStyle/>
+                    <a:p>
+                      <a:pPr indent="0" marL="0">
+                        <a:buNone/>
+                      </a:pPr>
+                      <a:r>
+                        <a:rPr lang="en-US" sz="1200" dirty="0">
+                          <a:solidFill>
+                            <a:srgbClr val="1B2430"/>
+                          </a:solidFill>
+                          <a:latin typeface="Calibri" pitchFamily="34" charset="0"/>
+                          <a:ea typeface="Calibri" pitchFamily="34" charset="-122"/>
+                          <a:cs typeface="Calibri" pitchFamily="34" charset="-120"/>
+                        </a:rPr>
+                        <a:t>RUDP Chat demo</a:t>
+                      </a:r>
+                      <a:endParaRPr lang="en-US" sz="1200" dirty="0">
+                        <a:latin typeface="Calibri" charset="0"/>
+                        <a:ea typeface="Calibri" charset="0"/>
+                        <a:cs typeface="Calibri" charset="0"/>
+                      </a:endParaRPr>
+                    </a:p>
+                  </a:txBody>
+                  <a:tcPr marL="91440" marR="91440" marT="45720" marB="45720">
+                    <a:lnL w="6350" cap="flat" cmpd="sng" algn="ctr">
+                      <a:solidFill>
+                        <a:srgbClr val="D5DEE9"/>
+                      </a:solidFill>
+                      <a:prstDash val="solid"/>
+                      <a:round/>
+                      <a:headEnd type="none" w="med" len="med"/>
+                      <a:tailEnd type="none" w="med" len="med"/>
+                    </a:lnL>
+                    <a:lnR w="6350" cap="flat" cmpd="sng" algn="ctr">
+                      <a:solidFill>
+                        <a:srgbClr val="D5DEE9"/>
+                      </a:solidFill>
+                      <a:prstDash val="solid"/>
+                      <a:round/>
+                      <a:headEnd type="none" w="med" len="med"/>
+                      <a:tailEnd type="none" w="med" len="med"/>
+                    </a:lnR>
+                    <a:lnT w="6350" cap="flat" cmpd="sng" algn="ctr">
+                      <a:solidFill>
+                        <a:srgbClr val="D5DEE9"/>
+                      </a:solidFill>
+                      <a:prstDash val="solid"/>
+                      <a:round/>
+                      <a:headEnd type="none" w="med" len="med"/>
+                      <a:tailEnd type="none" w="med" len="med"/>
+                    </a:lnT>
+                    <a:lnB w="6350" cap="flat" cmpd="sng" algn="ctr">
+                      <a:solidFill>
+                        <a:srgbClr val="D5DEE9"/>
+                      </a:solidFill>
+                      <a:prstDash val="solid"/>
+                      <a:round/>
+                      <a:headEnd type="none" w="med" len="med"/>
+                      <a:tailEnd type="none" w="med" len="med"/>
+                    </a:lnB>
+                  </a:tcPr>
+                </a:tc>
+                <a:tc>
+                  <a:txBody>
+                    <a:bodyPr/>
+                    <a:lstStyle/>
+                    <a:p>
+                      <a:pPr indent="0" marL="0">
+                        <a:buNone/>
+                      </a:pPr>
+                      <a:r>
+                        <a:rPr lang="en-US" sz="1200" dirty="0">
+                          <a:solidFill>
+                            <a:srgbClr val="1B2430"/>
+                          </a:solidFill>
+                          <a:latin typeface="Calibri" pitchFamily="34" charset="0"/>
+                          <a:ea typeface="Calibri" pitchFamily="34" charset="-122"/>
+                          <a:cs typeface="Calibri" pitchFamily="34" charset="-120"/>
+                        </a:rPr>
+                        <a:t>1:00</a:t>
+                      </a:r>
+                      <a:endParaRPr lang="en-US" sz="1200" dirty="0">
+                        <a:latin typeface="Calibri" charset="0"/>
+                        <a:ea typeface="Calibri" charset="0"/>
+                        <a:cs typeface="Calibri" charset="0"/>
+                      </a:endParaRPr>
+                    </a:p>
+                  </a:txBody>
+                  <a:tcPr marL="91440" marR="91440" marT="45720" marB="45720">
+                    <a:lnL w="6350" cap="flat" cmpd="sng" algn="ctr">
+                      <a:solidFill>
+                        <a:srgbClr val="D5DEE9"/>
+                      </a:solidFill>
+                      <a:prstDash val="solid"/>
+                      <a:round/>
+                      <a:headEnd type="none" w="med" len="med"/>
+                      <a:tailEnd type="none" w="med" len="med"/>
+                    </a:lnL>
+                    <a:lnR w="6350" cap="flat" cmpd="sng" algn="ctr">
+                      <a:solidFill>
+                        <a:srgbClr val="D5DEE9"/>
+                      </a:solidFill>
+                      <a:prstDash val="solid"/>
+                      <a:round/>
+                      <a:headEnd type="none" w="med" len="med"/>
+                      <a:tailEnd type="none" w="med" len="med"/>
+                    </a:lnR>
+                    <a:lnT w="6350" cap="flat" cmpd="sng" algn="ctr">
+                      <a:solidFill>
+                        <a:srgbClr val="D5DEE9"/>
+                      </a:solidFill>
+                      <a:prstDash val="solid"/>
+                      <a:round/>
+                      <a:headEnd type="none" w="med" len="med"/>
+                      <a:tailEnd type="none" w="med" len="med"/>
+                    </a:lnT>
+                    <a:lnB w="6350" cap="flat" cmpd="sng" algn="ctr">
+                      <a:solidFill>
+                        <a:srgbClr val="D5DEE9"/>
+                      </a:solidFill>
+                      <a:prstDash val="solid"/>
+                      <a:round/>
+                      <a:headEnd type="none" w="med" len="med"/>
+                      <a:tailEnd type="none" w="med" len="med"/>
+                    </a:lnB>
+                  </a:tcPr>
+                </a:tc>
+                <a:tc>
+                  <a:txBody>
+                    <a:bodyPr/>
+                    <a:lstStyle/>
+                    <a:p>
+                      <a:pPr indent="0" marL="0">
+                        <a:buNone/>
+                      </a:pPr>
                       <a:endParaRPr lang="en-US" sz="1200" dirty="0">
                         <a:latin typeface="Calibri" charset="0"/>
                         <a:ea typeface="Calibri" charset="0"/>
@@ -22482,7 +23052,7 @@
                 <a:ea typeface="Calibri" pitchFamily="34" charset="-122"/>
                 <a:cs typeface="Calibri" pitchFamily="34" charset="-120"/>
               </a:rPr>
-              <a:t>32. Reality check: real kernel (tc/netem)</a:t>
+              <a:t>32. How it was tested</a:t>
             </a:r>
             <a:endParaRPr lang="en-US" sz="2600" dirty="0"/>
           </a:p>
@@ -22521,7 +23091,7 @@
                 <a:ea typeface="Calibri" pitchFamily="34" charset="-122"/>
                 <a:cs typeface="Calibri" pitchFamily="34" charset="-120"/>
               </a:rPr>
-              <a:t>Time on this slide: 1:00</a:t>
+              <a:t>Time on this slide: 0:40</a:t>
             </a:r>
             <a:endParaRPr lang="en-US" sz="1300" dirty="0"/>
           </a:p>
@@ -22674,7 +23244,7 @@
                 <a:ea typeface="Calibri" pitchFamily="34" charset="-122"/>
                 <a:cs typeface="Calibri" pitchFamily="34" charset="-120"/>
               </a:rPr>
-              <a:t>Until now our real-socket tests ran through our own proxy. We repeated them on the Linux kernel itself, using tc netem, with kernel TCP in the same table.</a:t>
+              <a:t>Correctness first: unit, end-to-end, handshake, file-integrity, chat and simulator tests, and the packet parser is fuzzed under AddressSanitizer.</a:t>
             </a:r>
             <a:endParaRPr lang="en-US" sz="1400" dirty="0"/>
           </a:p>
@@ -22695,7 +23265,7 @@
                 <a:ea typeface="Calibri" pitchFamily="34" charset="-122"/>
                 <a:cs typeface="Calibri" pitchFamily="34" charset="-120"/>
               </a:rPr>
-              <a:t>Against tuned AIMD the neural agent is 71 percent faster on the lossy path, 65 percent on the 5G-like path and 83 percent on the satellite path, all significant. On the reordering path it is 60 percent faster but that is not significant.</a:t>
+              <a:t>For speed we use virtual time, which is the same C sender on a simulated clock. We checked it against the real clock, and it agreed in all 15 of 15 cells. We use paired seeds with 95 percent intervals and keep tuning seeds apart from test seeds.</a:t>
             </a:r>
             <a:endParaRPr lang="en-US" sz="1400" dirty="0"/>
           </a:p>
@@ -22716,49 +23286,7 @@
                 <a:ea typeface="Calibri" pitchFamily="34" charset="-122"/>
                 <a:cs typeface="Calibri" pitchFamily="34" charset="-120"/>
               </a:rPr>
-              <a:t>Kernel TCP is still faster than our agent on every path, by one and a half to one and seven tenths. We are not claiming to beat TCP.</a:t>
-            </a:r>
-            <a:endParaRPr lang="en-US" sz="1400" dirty="0"/>
-          </a:p>
-          <a:p>
-            <a:pPr marL="342900" indent="-342900">
-              <a:spcAft>
-                <a:spcPts val="600"/>
-              </a:spcAft>
-              <a:buSzPct val="100000"/>
-              <a:buChar char="•"/>
-            </a:pPr>
-            <a:r>
-              <a:rPr lang="en-US" sz="1400" dirty="0">
-                <a:solidFill>
-                  <a:srgbClr val="1B2430"/>
-                </a:solidFill>
-                <a:latin typeface="Calibri" pitchFamily="34" charset="0"/>
-                <a:ea typeface="Calibri" pitchFamily="34" charset="-122"/>
-                <a:cs typeface="Calibri" pitchFamily="34" charset="-120"/>
-              </a:rPr>
-              <a:t>We also put a kernel TCP flow and one RUDP flow on the same link. The neural agent takes 24 to 34 percent of it, so it does not starve TCP; tuned AIMD gets only 5 to 17 percent.</a:t>
-            </a:r>
-            <a:endParaRPr lang="en-US" sz="1400" dirty="0"/>
-          </a:p>
-          <a:p>
-            <a:pPr marL="342900" indent="-342900">
-              <a:spcAft>
-                <a:spcPts val="600"/>
-              </a:spcAft>
-              <a:buSzPct val="100000"/>
-              <a:buChar char="•"/>
-            </a:pPr>
-            <a:r>
-              <a:rPr lang="en-US" sz="1400" dirty="0">
-                <a:solidFill>
-                  <a:srgbClr val="1B2430"/>
-                </a:solidFill>
-                <a:latin typeface="Calibri" pitchFamily="34" charset="0"/>
-                <a:ea typeface="Calibri" pitchFamily="34" charset="-122"/>
-                <a:cs typeface="Calibri" pitchFamily="34" charset="-120"/>
-              </a:rPr>
-              <a:t>Our first runs were wrong four times: the netem queue limit counted packets in flight, the baseline was untuned, the payload sizes differed, and finally RUDP was sending 40-byte synthetic packets. We found each one, fixed it, re-ran everything and documented it.</a:t>
+              <a:t>Realism comes in four steps: emulation in the client, a separate proxy on real sockets, the Linux kernel with netem, and two laptops over the internet. Every result has its command in the report.</a:t>
             </a:r>
             <a:endParaRPr lang="en-US" sz="1400" dirty="0"/>
           </a:p>
@@ -22836,7 +23364,7 @@
                 <a:ea typeface="Calibri" pitchFamily="34" charset="-122"/>
                 <a:cs typeface="Calibri" pitchFamily="34" charset="-120"/>
               </a:rPr>
-              <a:t>Q: Does it beat TCP? A: No. It beats our AIMD baselines on a real kernel path; mature kernel TCP is faster, by 1.5x to 1.7x. Q: Does it starve TCP? A: No, it takes 24 to 34 percent of a shared link (3 runs per cell, one laptop). Q: Why were the first runs wrong? A: four separate mistakes, the last being 40-byte synthetic packets against 512-byte TCP payloads; all fixed and re-run.</a:t>
+              <a:t>Did you make mistakes? Yes, and we logged them: untuned baselines, unequal payloads, and synthetic 40-byte packets in the kernel test, each found, fixed and re-run.</a:t>
             </a:r>
             <a:endParaRPr lang="en-US" sz="1400" dirty="0"/>
           </a:p>
@@ -22907,7 +23435,7 @@
                 <a:ea typeface="Calibri" pitchFamily="34" charset="-122"/>
                 <a:cs typeface="Calibri" pitchFamily="34" charset="-120"/>
               </a:rPr>
-              <a:t>33. Research gaps: changing paths and a BBR baseline</a:t>
+              <a:t>33. Reality check: real kernel (tc/netem)</a:t>
             </a:r>
             <a:endParaRPr lang="en-US" sz="2600" dirty="0"/>
           </a:p>
@@ -23099,7 +23627,7 @@
                 <a:ea typeface="Calibri" pitchFamily="34" charset="-122"/>
                 <a:cs typeface="Calibri" pitchFamily="34" charset="-120"/>
               </a:rPr>
-              <a:t>Two more research gaps we tested.</a:t>
+              <a:t>Until now our real-socket tests ran through our own proxy. We repeated them on the Linux kernel itself, using tc netem, with kernel TCP in the same table.</a:t>
             </a:r>
             <a:endParaRPr lang="en-US" sz="1400" dirty="0"/>
           </a:p>
@@ -23120,7 +23648,7 @@
                 <a:ea typeface="Calibri" pitchFamily="34" charset="-122"/>
                 <a:cs typeface="Calibri" pitchFamily="34" charset="-120"/>
               </a:rPr>
-              <a:t>First, paths that change during a transfer: we added a --dyn option so bandwidth and delay change mid-run.</a:t>
+              <a:t>Against tuned AIMD the neural agent is 71 percent faster on the lossy path, 65 percent on the 5G-like path and 83 percent on the satellite path, all significant. On the reordering path it is 60 percent faster but that is not significant.</a:t>
             </a:r>
             <a:endParaRPr lang="en-US" sz="1400" dirty="0"/>
           </a:p>
@@ -23141,7 +23669,7 @@
                 <a:ea typeface="Calibri" pitchFamily="34" charset="-122"/>
                 <a:cs typeface="Calibri" pitchFamily="34" charset="-120"/>
               </a:rPr>
-              <a:t>The neural agent was fastest in all four cases, 6 to 53 percent faster than tuned AIMD, but it retransmits 1 to 6 percent of packets.</a:t>
+              <a:t>Kernel TCP is still faster than our agent on every path, by one and a half to one and seven tenths. We are not claiming to beat TCP.</a:t>
             </a:r>
             <a:endParaRPr lang="en-US" sz="1400" dirty="0"/>
           </a:p>
@@ -23162,7 +23690,7 @@
                 <a:ea typeface="Calibri" pitchFamily="34" charset="-122"/>
                 <a:cs typeface="Calibri" pitchFamily="34" charset="-120"/>
               </a:rPr>
-              <a:t>Second, a stronger baseline: a simplified BBR.</a:t>
+              <a:t>We also put a kernel TCP flow and one RUDP flow on the same link. The neural agent takes 24 to 34 percent of it, so it does not starve TCP; tuned AIMD gets only 5 to 17 percent.</a:t>
             </a:r>
             <a:endParaRPr lang="en-US" sz="1400" dirty="0"/>
           </a:p>
@@ -23183,28 +23711,7 @@
                 <a:ea typeface="Calibri" pitchFamily="34" charset="-122"/>
                 <a:cs typeface="Calibri" pitchFamily="34" charset="-120"/>
               </a:rPr>
-              <a:t>It beats tuned AIMD on four of five paths and is actually faster than our agent on the 2 percent lossy path, 8.2 seconds against 9.8.</a:t>
-            </a:r>
-            <a:endParaRPr lang="en-US" sz="1400" dirty="0"/>
-          </a:p>
-          <a:p>
-            <a:pPr marL="342900" indent="-342900">
-              <a:spcAft>
-                <a:spcPts val="600"/>
-              </a:spcAft>
-              <a:buSzPct val="100000"/>
-              <a:buChar char="•"/>
-            </a:pPr>
-            <a:r>
-              <a:rPr lang="en-US" sz="1400" dirty="0">
-                <a:solidFill>
-                  <a:srgbClr val="1B2430"/>
-                </a:solidFill>
-                <a:latin typeface="Calibri" pitchFamily="34" charset="0"/>
-                <a:ea typeface="Calibri" pitchFamily="34" charset="-122"/>
-                <a:cs typeface="Calibri" pitchFamily="34" charset="-120"/>
-              </a:rPr>
-              <a:t>Be honest that our BBR is a simplification and that two bugs in it were found and fixed by these tests.</a:t>
+              <a:t>Our first runs were wrong four times: the netem queue limit counted packets in flight, the baseline was untuned, the payload sizes differed, and finally RUDP was sending 40-byte synthetic packets. We found each one, fixed it, re-ran everything and documented it.</a:t>
             </a:r>
             <a:endParaRPr lang="en-US" sz="1400" dirty="0"/>
           </a:p>
@@ -23282,7 +23789,7 @@
                 <a:ea typeface="Calibri" pitchFamily="34" charset="-122"/>
                 <a:cs typeface="Calibri" pitchFamily="34" charset="-120"/>
               </a:rPr>
-              <a:t>Is your BBR the real one? No: a simplified version with no ProbeRTT and no BBRv3 loss response; the comparison is against a BBR-style policy.</a:t>
+              <a:t>Q: Does it beat TCP? A: No. It beats our AIMD baselines on a real kernel path; mature kernel TCP is faster, by 1.5x to 1.7x. Q: Does it starve TCP? A: No, it takes 24 to 34 percent of a shared link (3 runs per cell, one laptop). Q: Why were the first runs wrong? A: four separate mistakes, the last being 40-byte synthetic packets against 512-byte TCP payloads; all fixed and re-run.</a:t>
             </a:r>
             <a:endParaRPr lang="en-US" sz="1400" dirty="0"/>
           </a:p>
@@ -23353,7 +23860,7 @@
                 <a:ea typeface="Calibri" pitchFamily="34" charset="-122"/>
                 <a:cs typeface="Calibri" pitchFamily="34" charset="-120"/>
               </a:rPr>
-              <a:t>34. Research gaps: fairness and trust</a:t>
+              <a:t>34. Research gaps: changing paths and a BBR baseline</a:t>
             </a:r>
             <a:endParaRPr lang="en-US" sz="2600" dirty="0"/>
           </a:p>
@@ -23545,7 +24052,7 @@
                 <a:ea typeface="Calibri" pitchFamily="34" charset="-122"/>
                 <a:cs typeface="Calibri" pitchFamily="34" charset="-120"/>
               </a:rPr>
-              <a:t>Fairness and trust.</a:t>
+              <a:t>Two more research gaps we tested.</a:t>
             </a:r>
             <a:endParaRPr lang="en-US" sz="1400" dirty="0"/>
           </a:p>
@@ -23566,7 +24073,7 @@
                 <a:ea typeface="Calibri" pitchFamily="34" charset="-122"/>
                 <a:cs typeface="Calibri" pitchFamily="34" charset="-120"/>
               </a:rPr>
-              <a:t>Two neural flows with unequal round-trip times share the link more evenly than two AIMD flows, Jain 0.84 against 0.64 at 150 ms extra RTT, but still favour the short-RTT flow; six pairs per cell so only the largest gap is clear.</a:t>
+              <a:t>First, paths that change during a transfer: we added a --dyn option so bandwidth and delay change mid-run.</a:t>
             </a:r>
             <a:endParaRPr lang="en-US" sz="1400" dirty="0"/>
           </a:p>
@@ -23587,7 +24094,7 @@
                 <a:ea typeface="Calibri" pitchFamily="34" charset="-122"/>
                 <a:cs typeface="Calibri" pitchFamily="34" charset="-120"/>
               </a:rPr>
-              <a:t>A small decision tree agrees with the network on only 79 percent of decisions but gives the same transfer time on four of five paths.</a:t>
+              <a:t>The neural agent was fastest in all four cases, 6 to 53 percent faster than tuned AIMD, but it retransmits 1 to 6 percent of packets.</a:t>
             </a:r>
             <a:endParaRPr lang="en-US" sz="1400" dirty="0"/>
           </a:p>
@@ -23608,7 +24115,7 @@
                 <a:ea typeface="Calibri" pitchFamily="34" charset="-122"/>
                 <a:cs typeface="Calibri" pitchFamily="34" charset="-120"/>
               </a:rPr>
-              <a:t>Noise on the inputs costs at most 12 percent.</a:t>
+              <a:t>Second, a stronger baseline: a simplified BBR.</a:t>
             </a:r>
             <a:endParaRPr lang="en-US" sz="1400" dirty="0"/>
           </a:p>
@@ -23629,7 +24136,7 @@
                 <a:ea typeface="Calibri" pitchFamily="34" charset="-122"/>
                 <a:cs typeface="Calibri" pitchFamily="34" charset="-120"/>
               </a:rPr>
-              <a:t>Formal certification only works at tiny perturbations, so the agent is robust in practice but not proven.</a:t>
+              <a:t>It beats tuned AIMD on four of five paths and is actually faster than our agent on the 2 percent lossy path, 8.2 seconds against 9.8.</a:t>
             </a:r>
             <a:endParaRPr lang="en-US" sz="1400" dirty="0"/>
           </a:p>
@@ -23650,7 +24157,7 @@
                 <a:ea typeface="Calibri" pitchFamily="34" charset="-122"/>
                 <a:cs typeface="Calibri" pitchFamily="34" charset="-120"/>
               </a:rPr>
-              <a:t>Kernel TCP coexistence is measured: the neural agent takes 24 to 34 percent of a shared link, so it does not starve TCP, with only three runs per cell.</a:t>
+              <a:t>Be honest that our BBR is a simplification and that two bugs in it were found and fixed by these tests.</a:t>
             </a:r>
             <a:endParaRPr lang="en-US" sz="1400" dirty="0"/>
           </a:p>
@@ -23728,7 +24235,7 @@
                 <a:ea typeface="Calibri" pitchFamily="34" charset="-122"/>
                 <a:cs typeface="Calibri" pitchFamily="34" charset="-120"/>
               </a:rPr>
-              <a:t>Did you test against kernel TCP? Yes, on kernel netem: the neural agent took 24 to 34 percent of a shared link, three runs per cell on one laptop.</a:t>
+              <a:t>Is your BBR the real one? No: a simplified version with no ProbeRTT and no BBRv3 loss response; the comparison is against a BBR-style policy.</a:t>
             </a:r>
             <a:endParaRPr lang="en-US" sz="1400" dirty="0"/>
           </a:p>
@@ -23799,7 +24306,7 @@
                 <a:ea typeface="Calibri" pitchFamily="34" charset="-122"/>
                 <a:cs typeface="Calibri" pitchFamily="34" charset="-120"/>
               </a:rPr>
-              <a:t>35. Learnings and future work</a:t>
+              <a:t>35. Research gaps: fairness and trust</a:t>
             </a:r>
             <a:endParaRPr lang="en-US" sz="2600" dirty="0"/>
           </a:p>
@@ -23838,7 +24345,7 @@
                 <a:ea typeface="Calibri" pitchFamily="34" charset="-122"/>
                 <a:cs typeface="Calibri" pitchFamily="34" charset="-120"/>
               </a:rPr>
-              <a:t>Time on this slide: 0:50</a:t>
+              <a:t>Time on this slide: 1:00</a:t>
             </a:r>
             <a:endParaRPr lang="en-US" sz="1300" dirty="0"/>
           </a:p>
@@ -23991,7 +24498,7 @@
                 <a:ea typeface="Calibri" pitchFamily="34" charset="-122"/>
                 <a:cs typeface="Calibri" pitchFamily="34" charset="-120"/>
               </a:rPr>
-              <a:t>What we learned: reliability is a set of simple rules working together, congestion control matters as much as retransmission, and tests tell you things about your own results that you do not want to hear.</a:t>
+              <a:t>Fairness and trust.</a:t>
             </a:r>
             <a:endParaRPr lang="en-US" sz="1400" dirty="0"/>
           </a:p>
@@ -24012,7 +24519,7 @@
                 <a:ea typeface="Calibri" pitchFamily="34" charset="-122"/>
                 <a:cs typeface="Calibri" pitchFamily="34" charset="-120"/>
               </a:rPr>
-              <a:t>Our limits: no kernel netem or multi-machine test, the agent is not a polite neighbour, there is no gain at 10 percent random loss, and the tabular agent did not beat AIMD.</a:t>
+              <a:t>Two neural flows with unequal round-trip times share the link more evenly than two AIMD flows, Jain 0.84 against 0.64 at 150 ms extra RTT, but still favour the short-RTT flow; six pairs per cell so only the largest gap is clear.</a:t>
             </a:r>
             <a:endParaRPr lang="en-US" sz="1400" dirty="0"/>
           </a:p>
@@ -24033,7 +24540,70 @@
                 <a:ea typeface="Calibri" pitchFamily="34" charset="-122"/>
                 <a:cs typeface="Calibri" pitchFamily="34" charset="-120"/>
               </a:rPr>
-              <a:t>Next: fairness-aware training with TCP coexistence, training on real traces, and kernel and multi-machine tests.</a:t>
+              <a:t>A small decision tree agrees with the network on only 79 percent of decisions but gives the same transfer time on four of five paths.</a:t>
+            </a:r>
+            <a:endParaRPr lang="en-US" sz="1400" dirty="0"/>
+          </a:p>
+          <a:p>
+            <a:pPr marL="342900" indent="-342900">
+              <a:spcAft>
+                <a:spcPts val="600"/>
+              </a:spcAft>
+              <a:buSzPct val="100000"/>
+              <a:buChar char="•"/>
+            </a:pPr>
+            <a:r>
+              <a:rPr lang="en-US" sz="1400" dirty="0">
+                <a:solidFill>
+                  <a:srgbClr val="1B2430"/>
+                </a:solidFill>
+                <a:latin typeface="Calibri" pitchFamily="34" charset="0"/>
+                <a:ea typeface="Calibri" pitchFamily="34" charset="-122"/>
+                <a:cs typeface="Calibri" pitchFamily="34" charset="-120"/>
+              </a:rPr>
+              <a:t>Noise on the inputs costs at most 12 percent.</a:t>
+            </a:r>
+            <a:endParaRPr lang="en-US" sz="1400" dirty="0"/>
+          </a:p>
+          <a:p>
+            <a:pPr marL="342900" indent="-342900">
+              <a:spcAft>
+                <a:spcPts val="600"/>
+              </a:spcAft>
+              <a:buSzPct val="100000"/>
+              <a:buChar char="•"/>
+            </a:pPr>
+            <a:r>
+              <a:rPr lang="en-US" sz="1400" dirty="0">
+                <a:solidFill>
+                  <a:srgbClr val="1B2430"/>
+                </a:solidFill>
+                <a:latin typeface="Calibri" pitchFamily="34" charset="0"/>
+                <a:ea typeface="Calibri" pitchFamily="34" charset="-122"/>
+                <a:cs typeface="Calibri" pitchFamily="34" charset="-120"/>
+              </a:rPr>
+              <a:t>Formal certification only works at tiny perturbations, so the agent is robust in practice but not proven.</a:t>
+            </a:r>
+            <a:endParaRPr lang="en-US" sz="1400" dirty="0"/>
+          </a:p>
+          <a:p>
+            <a:pPr marL="342900" indent="-342900">
+              <a:spcAft>
+                <a:spcPts val="600"/>
+              </a:spcAft>
+              <a:buSzPct val="100000"/>
+              <a:buChar char="•"/>
+            </a:pPr>
+            <a:r>
+              <a:rPr lang="en-US" sz="1400" dirty="0">
+                <a:solidFill>
+                  <a:srgbClr val="1B2430"/>
+                </a:solidFill>
+                <a:latin typeface="Calibri" pitchFamily="34" charset="0"/>
+                <a:ea typeface="Calibri" pitchFamily="34" charset="-122"/>
+                <a:cs typeface="Calibri" pitchFamily="34" charset="-120"/>
+              </a:rPr>
+              <a:t>Kernel TCP coexistence is measured: the neural agent takes 24 to 34 percent of a shared link, so it does not starve TCP, with only three runs per cell.</a:t>
             </a:r>
             <a:endParaRPr lang="en-US" sz="1400" dirty="0"/>
           </a:p>
@@ -24111,7 +24681,7 @@
                 <a:ea typeface="Calibri" pitchFamily="34" charset="-122"/>
                 <a:cs typeface="Calibri" pitchFamily="34" charset="-120"/>
               </a:rPr>
-              <a:t>What would you do first? Run the netem script on a Linux machine for kernel TCP and RUDP on the same path, then add a competing flow to the training.</a:t>
+              <a:t>Did you test against kernel TCP? Yes, on kernel netem: the neural agent took 24 to 34 percent of a shared link, three runs per cell on one laptop.</a:t>
             </a:r>
             <a:endParaRPr lang="en-US" sz="1400" dirty="0"/>
           </a:p>
@@ -24182,7 +24752,7 @@
                 <a:ea typeface="Calibri" pitchFamily="34" charset="-122"/>
                 <a:cs typeface="Calibri" pitchFamily="34" charset="-120"/>
               </a:rPr>
-              <a:t>36. Thank you</a:t>
+              <a:t>36. First run between two machines</a:t>
             </a:r>
             <a:endParaRPr lang="en-US" sz="2600" dirty="0"/>
           </a:p>
@@ -24221,7 +24791,7 @@
                 <a:ea typeface="Calibri" pitchFamily="34" charset="-122"/>
                 <a:cs typeface="Calibri" pitchFamily="34" charset="-120"/>
               </a:rPr>
-              <a:t>Time on this slide: 0:15</a:t>
+              <a:t>Time on this slide: 0:45</a:t>
             </a:r>
             <a:endParaRPr lang="en-US" sz="1300" dirty="0"/>
           </a:p>
@@ -24366,7 +24936,7 @@
               <a:buChar char="•"/>
             </a:pPr>
             <a:r>
-              <a:rPr lang="en-US" sz="1600" dirty="0">
+              <a:rPr lang="en-US" sz="1400" dirty="0">
                 <a:solidFill>
                   <a:srgbClr val="1B2430"/>
                 </a:solidFill>
@@ -24374,9 +24944,51 @@
                 <a:ea typeface="Calibri" pitchFamily="34" charset="-122"/>
                 <a:cs typeface="Calibri" pitchFamily="34" charset="-120"/>
               </a:rPr>
-              <a:t>Thank you. The code, report and captures are at github.com/Capsturrrr/rudp. Happy to take questions.</a:t>
-            </a:r>
-            <a:endParaRPr lang="en-US" sz="1600" dirty="0"/>
+              <a:t>Until now every test ran on one computer. We ran the sender on one laptop and the receiver on another, on different networks, joined by Tailscale. It could not connect directly, so traffic went through a relay, about 79 milliseconds round trip.</a:t>
+            </a:r>
+            <a:endParaRPr lang="en-US" sz="1400" dirty="0"/>
+          </a:p>
+          <a:p>
+            <a:pPr marL="342900" indent="-342900">
+              <a:spcAft>
+                <a:spcPts val="600"/>
+              </a:spcAft>
+              <a:buSzPct val="100000"/>
+              <a:buChar char="•"/>
+            </a:pPr>
+            <a:r>
+              <a:rPr lang="en-US" sz="1400" dirty="0">
+                <a:solidFill>
+                  <a:srgbClr val="1B2430"/>
+                </a:solidFill>
+                <a:latin typeface="Calibri" pitchFamily="34" charset="0"/>
+                <a:ea typeface="Calibri" pitchFamily="34" charset="-122"/>
+                <a:cs typeface="Calibri" pitchFamily="34" charset="-120"/>
+              </a:rPr>
+              <a:t>RUDP works between real machines: every transfer that finished delivered all 4,000 packets, with all four policies.</a:t>
+            </a:r>
+            <a:endParaRPr lang="en-US" sz="1400" dirty="0"/>
+          </a:p>
+          <a:p>
+            <a:pPr marL="342900" indent="-342900">
+              <a:spcAft>
+                <a:spcPts val="600"/>
+              </a:spcAft>
+              <a:buSzPct val="100000"/>
+              <a:buChar char="•"/>
+            </a:pPr>
+            <a:r>
+              <a:rPr lang="en-US" sz="1400" dirty="0">
+                <a:solidFill>
+                  <a:srgbClr val="1B2430"/>
+                </a:solidFill>
+                <a:latin typeface="Calibri" pitchFamily="34" charset="0"/>
+                <a:ea typeface="Calibri" pitchFamily="34" charset="-122"/>
+                <a:cs typeface="Calibri" pitchFamily="34" charset="-120"/>
+              </a:rPr>
+              <a:t>Be honest about the numbers: the path drifted, kernel TCP alone took anywhere from 2 to 51 seconds, and 4 of 20 RUDP runs timed out, so this is a demonstration and not a ranking. On the two clean repetitions kernel TCP was 2 to 6 times faster, and in repetition 1 the neural agent beat tuned AIMD, 4.7 against 14.2 seconds.</a:t>
+            </a:r>
+            <a:endParaRPr lang="en-US" sz="1400" dirty="0"/>
           </a:p>
         </p:txBody>
       </p:sp>
@@ -24452,7 +25064,7 @@
                 <a:ea typeface="Calibri" pitchFamily="34" charset="-122"/>
                 <a:cs typeface="Calibri" pitchFamily="34" charset="-120"/>
               </a:rPr>
-              <a:t>Pause and smile; hand over to questions.</a:t>
+              <a:t>Why not a better test? The other laptop was a one-time setup over the internet; the next step is a direct local network with more repetitions.</a:t>
             </a:r>
             <a:endParaRPr lang="en-US" sz="1400" dirty="0"/>
           </a:p>
@@ -24523,7 +25135,7 @@
                 <a:ea typeface="Calibri" pitchFamily="34" charset="-122"/>
                 <a:cs typeface="Calibri" pitchFamily="34" charset="-120"/>
               </a:rPr>
-              <a:t>37. Appendix: slow start</a:t>
+              <a:t>37. Learnings and future work</a:t>
             </a:r>
             <a:endParaRPr lang="en-US" sz="2600" dirty="0"/>
           </a:p>
@@ -24562,7 +25174,7 @@
                 <a:ea typeface="Calibri" pitchFamily="34" charset="-122"/>
                 <a:cs typeface="Calibri" pitchFamily="34" charset="-120"/>
               </a:rPr>
-              <a:t>Time on this slide: -</a:t>
+              <a:t>Time on this slide: 0:50</a:t>
             </a:r>
             <a:endParaRPr lang="en-US" sz="1300" dirty="0"/>
           </a:p>
@@ -24707,7 +25319,7 @@
               <a:buChar char="•"/>
             </a:pPr>
             <a:r>
-              <a:rPr lang="en-US" sz="1600" dirty="0">
+              <a:rPr lang="en-US" sz="1400" dirty="0">
                 <a:solidFill>
                   <a:srgbClr val="1B2430"/>
                 </a:solidFill>
@@ -24715,9 +25327,51 @@
                 <a:ea typeface="Calibri" pitchFamily="34" charset="-122"/>
                 <a:cs typeface="Calibri" pitchFamily="34" charset="-120"/>
               </a:rPr>
-              <a:t>Only if asked: the window starts at 1, adds 1 per ACK until the threshold 16, then 1/window per ACK. In the 62-packet run the final window was 18.71.</a:t>
-            </a:r>
-            <a:endParaRPr lang="en-US" sz="1600" dirty="0"/>
+              <a:t>What we learned: reliability is a set of simple rules working together, congestion control matters as much as retransmission, and tests tell you things about your own results that you do not want to hear.</a:t>
+            </a:r>
+            <a:endParaRPr lang="en-US" sz="1400" dirty="0"/>
+          </a:p>
+          <a:p>
+            <a:pPr marL="342900" indent="-342900">
+              <a:spcAft>
+                <a:spcPts val="600"/>
+              </a:spcAft>
+              <a:buSzPct val="100000"/>
+              <a:buChar char="•"/>
+            </a:pPr>
+            <a:r>
+              <a:rPr lang="en-US" sz="1400" dirty="0">
+                <a:solidFill>
+                  <a:srgbClr val="1B2430"/>
+                </a:solidFill>
+                <a:latin typeface="Calibri" pitchFamily="34" charset="0"/>
+                <a:ea typeface="Calibri" pitchFamily="34" charset="-122"/>
+                <a:cs typeface="Calibri" pitchFamily="34" charset="-120"/>
+              </a:rPr>
+              <a:t>Our limits: only one noisy two-machine run, the agent is not a polite neighbour, there is no gain at 10 percent random loss, and the tabular agent did not beat AIMD.</a:t>
+            </a:r>
+            <a:endParaRPr lang="en-US" sz="1400" dirty="0"/>
+          </a:p>
+          <a:p>
+            <a:pPr marL="342900" indent="-342900">
+              <a:spcAft>
+                <a:spcPts val="600"/>
+              </a:spcAft>
+              <a:buSzPct val="100000"/>
+              <a:buChar char="•"/>
+            </a:pPr>
+            <a:r>
+              <a:rPr lang="en-US" sz="1400" dirty="0">
+                <a:solidFill>
+                  <a:srgbClr val="1B2430"/>
+                </a:solidFill>
+                <a:latin typeface="Calibri" pitchFamily="34" charset="0"/>
+                <a:ea typeface="Calibri" pitchFamily="34" charset="-122"/>
+                <a:cs typeface="Calibri" pitchFamily="34" charset="-120"/>
+              </a:rPr>
+              <a:t>Next: fairness-aware training with TCP coexistence, training on real traces, and controlled multi-machine tests.</a:t>
+            </a:r>
+            <a:endParaRPr lang="en-US" sz="1400" dirty="0"/>
           </a:p>
         </p:txBody>
       </p:sp>
@@ -24793,7 +25447,7 @@
                 <a:ea typeface="Calibri" pitchFamily="34" charset="-122"/>
                 <a:cs typeface="Calibri" pitchFamily="34" charset="-120"/>
               </a:rPr>
-              <a:t>Use this slide to answer 'show me congestion avoidance'.</a:t>
+              <a:t>What would you do first? Run the netem script on a Linux machine for kernel TCP and RUDP on the same path, then add a competing flow to the training.</a:t>
             </a:r>
             <a:endParaRPr lang="en-US" sz="1400" dirty="0"/>
           </a:p>
@@ -25268,7 +25922,7 @@
                 <a:ea typeface="Calibri" pitchFamily="34" charset="-122"/>
                 <a:cs typeface="Calibri" pitchFamily="34" charset="-120"/>
               </a:rPr>
-              <a:t>Hard questions and short answers (1 of 3)</a:t>
+              <a:t>38. Thank you</a:t>
             </a:r>
             <a:endParaRPr lang="en-US" sz="2600" dirty="0"/>
           </a:p>
@@ -25276,7 +25930,46 @@
       </p:sp>
       <p:sp>
         <p:nvSpPr>
-          <p:cNvPr id="3" name="Shape 1"/>
+          <p:cNvPr id="3" name="Text 1"/>
+          <p:cNvSpPr/>
+          <p:nvPr/>
+        </p:nvSpPr>
+        <p:spPr>
+          <a:xfrm>
+            <a:off x="457200" y="804672"/>
+            <a:ext cx="10972800" cy="320040"/>
+          </a:xfrm>
+          <a:prstGeom prst="rect">
+            <a:avLst/>
+          </a:prstGeom>
+          <a:noFill/>
+          <a:ln/>
+        </p:spPr>
+        <p:txBody>
+          <a:bodyPr wrap="square" lIns="0" tIns="0" rIns="0" bIns="0" rtlCol="0" anchor="ctr"/>
+          <a:lstStyle/>
+          <a:p>
+            <a:pPr indent="0" marL="0">
+              <a:buNone/>
+            </a:pPr>
+            <a:r>
+              <a:rPr lang="en-US" sz="1300" dirty="0">
+                <a:solidFill>
+                  <a:srgbClr val="5B6775"/>
+                </a:solidFill>
+                <a:latin typeface="Calibri" pitchFamily="34" charset="0"/>
+                <a:ea typeface="Calibri" pitchFamily="34" charset="-122"/>
+                <a:cs typeface="Calibri" pitchFamily="34" charset="-120"/>
+              </a:rPr>
+              <a:t>Time on this slide: 0:15</a:t>
+            </a:r>
+            <a:endParaRPr lang="en-US" sz="1300" dirty="0"/>
+          </a:p>
+        </p:txBody>
+      </p:sp>
+      <p:sp>
+        <p:nvSpPr>
+          <p:cNvPr id="4" name="Shape 2"/>
           <p:cNvSpPr/>
           <p:nvPr/>
         </p:nvSpPr>
@@ -25299,26 +25992,47 @@
           </a:ln>
         </p:spPr>
       </p:sp>
-      <p:sp>
-        <p:nvSpPr>
-          <p:cNvPr id="4" name="Shape 2"/>
-          <p:cNvSpPr/>
-          <p:nvPr/>
-        </p:nvSpPr>
+      <p:pic>
+        <p:nvPicPr>
+          <p:cNvPr id="5" name="Image 0" descr="th-38.png">    </p:cNvPr>
+          <p:cNvPicPr>
+            <a:picLocks noChangeAspect="1"/>
+          </p:cNvPicPr>
+          <p:nvPr/>
+        </p:nvPicPr>
+        <p:blipFill>
+          <a:blip r:embed="rId1"/>
+          <a:stretch>
+            <a:fillRect/>
+          </a:stretch>
+        </p:blipFill>
         <p:spPr>
           <a:xfrm>
             <a:off x="457200" y="1371600"/>
-            <a:ext cx="11274552" cy="914400"/>
-          </a:xfrm>
-          <a:prstGeom prst="rect">
-            <a:avLst/>
-          </a:prstGeom>
-          <a:solidFill>
-            <a:srgbClr val="F2F6FB"/>
-          </a:solidFill>
-          <a:ln w="9525">
+            <a:ext cx="5669280" cy="3188970"/>
+          </a:xfrm>
+          <a:prstGeom prst="rect">
+            <a:avLst/>
+          </a:prstGeom>
+        </p:spPr>
+      </p:pic>
+      <p:sp>
+        <p:nvSpPr>
+          <p:cNvPr id="6" name="Shape 3"/>
+          <p:cNvSpPr/>
+          <p:nvPr/>
+        </p:nvSpPr>
+        <p:spPr>
+          <a:xfrm>
+            <a:off x="457200" y="1371600"/>
+            <a:ext cx="5669280" cy="3188970"/>
+          </a:xfrm>
+          <a:prstGeom prst="rect">
+            <a:avLst/>
+          </a:prstGeom>
+          <a:ln w="12700">
             <a:solidFill>
-              <a:srgbClr val="D5DEE9"/>
+              <a:srgbClr val="C9D3E0"/>
             </a:solidFill>
             <a:prstDash val="solid"/>
           </a:ln>
@@ -25326,14 +26040,14 @@
       </p:sp>
       <p:sp>
         <p:nvSpPr>
-          <p:cNvPr id="5" name="Text 3"/>
-          <p:cNvSpPr/>
-          <p:nvPr/>
-        </p:nvSpPr>
-        <p:spPr>
-          <a:xfrm>
-            <a:off x="640080" y="1417320"/>
-            <a:ext cx="10972800" cy="320040"/>
+          <p:cNvPr id="7" name="Text 4"/>
+          <p:cNvSpPr/>
+          <p:nvPr/>
+        </p:nvSpPr>
+        <p:spPr>
+          <a:xfrm>
+            <a:off x="6400800" y="1325880"/>
+            <a:ext cx="1828800" cy="320040"/>
           </a:xfrm>
           <a:prstGeom prst="rect">
             <a:avLst/>
@@ -25349,7 +26063,7 @@
               <a:buNone/>
             </a:pPr>
             <a:r>
-              <a:rPr lang="en-US" sz="1500" b="1" dirty="0">
+              <a:rPr lang="en-US" sz="1300" b="1" dirty="0">
                 <a:solidFill>
                   <a:srgbClr val="1F6FEB"/>
                 </a:solidFill>
@@ -25357,22 +26071,22 @@
                 <a:ea typeface="Calibri" pitchFamily="34" charset="-122"/>
                 <a:cs typeface="Calibri" pitchFamily="34" charset="-120"/>
               </a:rPr>
-              <a:t>Is this a lab exercise?</a:t>
-            </a:r>
-            <a:endParaRPr lang="en-US" sz="1500" dirty="0"/>
-          </a:p>
-        </p:txBody>
-      </p:sp>
-      <p:sp>
-        <p:nvSpPr>
-          <p:cNvPr id="6" name="Text 4"/>
-          <p:cNvSpPr/>
-          <p:nvPr/>
-        </p:nvSpPr>
-        <p:spPr>
-          <a:xfrm>
-            <a:off x="640080" y="1737360"/>
-            <a:ext cx="10972800" cy="530352"/>
+              <a:t>SAY</a:t>
+            </a:r>
+            <a:endParaRPr lang="en-US" sz="1300" dirty="0"/>
+          </a:p>
+        </p:txBody>
+      </p:sp>
+      <p:sp>
+        <p:nvSpPr>
+          <p:cNvPr id="8" name="Text 5"/>
+          <p:cNvSpPr/>
+          <p:nvPr/>
+        </p:nvSpPr>
+        <p:spPr>
+          <a:xfrm>
+            <a:off x="6400800" y="1645920"/>
+            <a:ext cx="5349240" cy="3017520"/>
           </a:xfrm>
           <a:prstGeom prst="rect">
             <a:avLst/>
@@ -25384,11 +26098,15 @@
           <a:bodyPr wrap="square" lIns="0" tIns="0" rIns="0" bIns="0" rtlCol="0" anchor="t"/>
           <a:lstStyle/>
           <a:p>
-            <a:pPr indent="0" marL="0">
-              <a:buNone/>
-            </a:pPr>
-            <a:r>
-              <a:rPr lang="en-US" sz="1350" dirty="0">
+            <a:pPr marL="342900" indent="-342900">
+              <a:spcAft>
+                <a:spcPts val="600"/>
+              </a:spcAft>
+              <a:buSzPct val="100000"/>
+              <a:buChar char="•"/>
+            </a:pPr>
+            <a:r>
+              <a:rPr lang="en-US" sz="1600" dirty="0">
                 <a:solidFill>
                   <a:srgbClr val="1B2430"/>
                 </a:solidFill>
@@ -25396,32 +26114,32 @@
                 <a:ea typeface="Calibri" pitchFamily="34" charset="-122"/>
                 <a:cs typeface="Calibri" pitchFamily="34" charset="-120"/>
               </a:rPr>
-              <a:t>A lab sends datagrams. We built reliability and congestion control on top, measured them, and used them in a real chat and a routed network.</a:t>
-            </a:r>
-            <a:endParaRPr lang="en-US" sz="1350" dirty="0"/>
-          </a:p>
-        </p:txBody>
-      </p:sp>
-      <p:sp>
-        <p:nvSpPr>
-          <p:cNvPr id="7" name="Shape 5"/>
-          <p:cNvSpPr/>
-          <p:nvPr/>
-        </p:nvSpPr>
-        <p:spPr>
-          <a:xfrm>
-            <a:off x="457200" y="2377440"/>
-            <a:ext cx="11274552" cy="914400"/>
+              <a:t>Thank you. The code, report and captures are at github.com/Capsturrrr/rudp. Happy to take questions.</a:t>
+            </a:r>
+            <a:endParaRPr lang="en-US" sz="1600" dirty="0"/>
+          </a:p>
+        </p:txBody>
+      </p:sp>
+      <p:sp>
+        <p:nvSpPr>
+          <p:cNvPr id="9" name="Shape 6"/>
+          <p:cNvSpPr/>
+          <p:nvPr/>
+        </p:nvSpPr>
+        <p:spPr>
+          <a:xfrm>
+            <a:off x="457200" y="4709160"/>
+            <a:ext cx="5669280" cy="1737360"/>
           </a:xfrm>
           <a:prstGeom prst="rect">
             <a:avLst/>
           </a:prstGeom>
           <a:solidFill>
-            <a:srgbClr val="F2F6FB"/>
+            <a:srgbClr val="FFF6E5"/>
           </a:solidFill>
-          <a:ln w="9525">
+          <a:ln w="12700">
             <a:solidFill>
-              <a:srgbClr val="D5DEE9"/>
+              <a:srgbClr val="F0C987"/>
             </a:solidFill>
             <a:prstDash val="solid"/>
           </a:ln>
@@ -25429,14 +26147,14 @@
       </p:sp>
       <p:sp>
         <p:nvSpPr>
-          <p:cNvPr id="8" name="Text 6"/>
-          <p:cNvSpPr/>
-          <p:nvPr/>
-        </p:nvSpPr>
-        <p:spPr>
-          <a:xfrm>
-            <a:off x="640080" y="2423160"/>
-            <a:ext cx="10972800" cy="320040"/>
+          <p:cNvPr id="10" name="Text 7"/>
+          <p:cNvSpPr/>
+          <p:nvPr/>
+        </p:nvSpPr>
+        <p:spPr>
+          <a:xfrm>
+            <a:off x="594360" y="4754880"/>
+            <a:ext cx="5394960" cy="1645920"/>
           </a:xfrm>
           <a:prstGeom prst="rect">
             <a:avLst/>
@@ -25445,53 +26163,28 @@
           <a:ln/>
         </p:spPr>
         <p:txBody>
-          <a:bodyPr wrap="square" lIns="0" tIns="0" rIns="0" bIns="0" rtlCol="0" anchor="ctr"/>
+          <a:bodyPr wrap="square" lIns="0" tIns="0" rIns="0" bIns="0" rtlCol="0" anchor="t"/>
           <a:lstStyle/>
           <a:p>
             <a:pPr indent="0" marL="0">
               <a:buNone/>
             </a:pPr>
             <a:r>
-              <a:rPr lang="en-US" sz="1500" b="1" dirty="0">
-                <a:solidFill>
-                  <a:srgbClr val="1F6FEB"/>
-                </a:solidFill>
-                <a:latin typeface="Calibri" pitchFamily="34" charset="0"/>
-                <a:ea typeface="Calibri" pitchFamily="34" charset="-122"/>
-                <a:cs typeface="Calibri" pitchFamily="34" charset="-120"/>
-              </a:rPr>
-              <a:t>Why not TCP?</a:t>
-            </a:r>
-            <a:endParaRPr lang="en-US" sz="1500" dirty="0"/>
-          </a:p>
-        </p:txBody>
-      </p:sp>
-      <p:sp>
-        <p:nvSpPr>
-          <p:cNvPr id="9" name="Text 7"/>
-          <p:cNvSpPr/>
-          <p:nvPr/>
-        </p:nvSpPr>
-        <p:spPr>
-          <a:xfrm>
-            <a:off x="640080" y="2743200"/>
-            <a:ext cx="10972800" cy="530352"/>
-          </a:xfrm>
-          <a:prstGeom prst="rect">
-            <a:avLst/>
-          </a:prstGeom>
-          <a:noFill/>
-          <a:ln/>
-        </p:spPr>
-        <p:txBody>
-          <a:bodyPr wrap="square" lIns="0" tIns="0" rIns="0" bIns="0" rtlCol="0" anchor="t"/>
-          <a:lstStyle/>
-          <a:p>
+              <a:rPr lang="en-US" sz="1400" b="1" dirty="0">
+                <a:solidFill>
+                  <a:srgbClr val="B45309"/>
+                </a:solidFill>
+                <a:latin typeface="Calibri" pitchFamily="34" charset="0"/>
+                <a:ea typeface="Calibri" pitchFamily="34" charset="-122"/>
+                <a:cs typeface="Calibri" pitchFamily="34" charset="-120"/>
+              </a:rPr>
+              <a:t>IF ASKED  </a:t>
+            </a:r>
             <a:pPr indent="0" marL="0">
               <a:buNone/>
             </a:pPr>
             <a:r>
-              <a:rPr lang="en-US" sz="1350" dirty="0">
+              <a:rPr lang="en-US" sz="1400" dirty="0">
                 <a:solidFill>
                   <a:srgbClr val="1B2430"/>
                 </a:solidFill>
@@ -25499,318 +26192,9 @@
                 <a:ea typeface="Calibri" pitchFamily="34" charset="-122"/>
                 <a:cs typeface="Calibri" pitchFamily="34" charset="-120"/>
               </a:rPr>
-              <a:t>TCP is in the kernel and cannot be changed. Building our own makes every mechanism visible. QUIC and HTTP/3 do the same.</a:t>
-            </a:r>
-            <a:endParaRPr lang="en-US" sz="1350" dirty="0"/>
-          </a:p>
-        </p:txBody>
-      </p:sp>
-      <p:sp>
-        <p:nvSpPr>
-          <p:cNvPr id="10" name="Shape 8"/>
-          <p:cNvSpPr/>
-          <p:nvPr/>
-        </p:nvSpPr>
-        <p:spPr>
-          <a:xfrm>
-            <a:off x="457200" y="3383280"/>
-            <a:ext cx="11274552" cy="914400"/>
-          </a:xfrm>
-          <a:prstGeom prst="rect">
-            <a:avLst/>
-          </a:prstGeom>
-          <a:solidFill>
-            <a:srgbClr val="F2F6FB"/>
-          </a:solidFill>
-          <a:ln w="9525">
-            <a:solidFill>
-              <a:srgbClr val="D5DEE9"/>
-            </a:solidFill>
-            <a:prstDash val="solid"/>
-          </a:ln>
-        </p:spPr>
-      </p:sp>
-      <p:sp>
-        <p:nvSpPr>
-          <p:cNvPr id="11" name="Text 9"/>
-          <p:cNvSpPr/>
-          <p:nvPr/>
-        </p:nvSpPr>
-        <p:spPr>
-          <a:xfrm>
-            <a:off x="640080" y="3429000"/>
-            <a:ext cx="10972800" cy="320040"/>
-          </a:xfrm>
-          <a:prstGeom prst="rect">
-            <a:avLst/>
-          </a:prstGeom>
-          <a:noFill/>
-          <a:ln/>
-        </p:spPr>
-        <p:txBody>
-          <a:bodyPr wrap="square" lIns="0" tIns="0" rIns="0" bIns="0" rtlCol="0" anchor="ctr"/>
-          <a:lstStyle/>
-          <a:p>
-            <a:pPr indent="0" marL="0">
-              <a:buNone/>
-            </a:pPr>
-            <a:r>
-              <a:rPr lang="en-US" sz="1500" b="1" dirty="0">
-                <a:solidFill>
-                  <a:srgbClr val="1F6FEB"/>
-                </a:solidFill>
-                <a:latin typeface="Calibri" pitchFamily="34" charset="0"/>
-                <a:ea typeface="Calibri" pitchFamily="34" charset="-122"/>
-                <a:cs typeface="Calibri" pitchFamily="34" charset="-120"/>
-              </a:rPr>
-              <a:t>Did Smart-RUDP win?</a:t>
-            </a:r>
-            <a:endParaRPr lang="en-US" sz="1500" dirty="0"/>
-          </a:p>
-        </p:txBody>
-      </p:sp>
-      <p:sp>
-        <p:nvSpPr>
-          <p:cNvPr id="12" name="Text 10"/>
-          <p:cNvSpPr/>
-          <p:nvPr/>
-        </p:nvSpPr>
-        <p:spPr>
-          <a:xfrm>
-            <a:off x="640080" y="3749040"/>
-            <a:ext cx="10972800" cy="530352"/>
-          </a:xfrm>
-          <a:prstGeom prst="rect">
-            <a:avLst/>
-          </a:prstGeom>
-          <a:noFill/>
-          <a:ln/>
-        </p:spPr>
-        <p:txBody>
-          <a:bodyPr wrap="square" lIns="0" tIns="0" rIns="0" bIns="0" rtlCol="0" anchor="t"/>
-          <a:lstStyle/>
-          <a:p>
-            <a:pPr indent="0" marL="0">
-              <a:buNone/>
-            </a:pPr>
-            <a:r>
-              <a:rPr lang="en-US" sz="1350" dirty="0">
-                <a:solidFill>
-                  <a:srgbClr val="1B2430"/>
-                </a:solidFill>
-                <a:latin typeface="Calibri" pitchFamily="34" charset="0"/>
-                <a:ea typeface="Calibri" pitchFamily="34" charset="-122"/>
-                <a:cs typeface="Calibri" pitchFamily="34" charset="-120"/>
-              </a:rPr>
-              <a:t>Yes, in the final C transport against tuned baselines: 15 to 52 percent less time than tuned AIMD on four ordinary paths (real clock, real sockets and 100 random held-out paths agree), a tie on the 10 percent loss path. Against a simplified BBR it wins on the satellite-like and fast paths and loses on the 2 percent lossy path. The first tabular agent did not beat AIMD, and we say so.</a:t>
-            </a:r>
-            <a:endParaRPr lang="en-US" sz="1350" dirty="0"/>
-          </a:p>
-        </p:txBody>
-      </p:sp>
-      <p:sp>
-        <p:nvSpPr>
-          <p:cNvPr id="13" name="Shape 11"/>
-          <p:cNvSpPr/>
-          <p:nvPr/>
-        </p:nvSpPr>
-        <p:spPr>
-          <a:xfrm>
-            <a:off x="457200" y="4389120"/>
-            <a:ext cx="11274552" cy="914400"/>
-          </a:xfrm>
-          <a:prstGeom prst="rect">
-            <a:avLst/>
-          </a:prstGeom>
-          <a:solidFill>
-            <a:srgbClr val="F2F6FB"/>
-          </a:solidFill>
-          <a:ln w="9525">
-            <a:solidFill>
-              <a:srgbClr val="D5DEE9"/>
-            </a:solidFill>
-            <a:prstDash val="solid"/>
-          </a:ln>
-        </p:spPr>
-      </p:sp>
-      <p:sp>
-        <p:nvSpPr>
-          <p:cNvPr id="14" name="Text 12"/>
-          <p:cNvSpPr/>
-          <p:nvPr/>
-        </p:nvSpPr>
-        <p:spPr>
-          <a:xfrm>
-            <a:off x="640080" y="4434840"/>
-            <a:ext cx="10972800" cy="320040"/>
-          </a:xfrm>
-          <a:prstGeom prst="rect">
-            <a:avLst/>
-          </a:prstGeom>
-          <a:noFill/>
-          <a:ln/>
-        </p:spPr>
-        <p:txBody>
-          <a:bodyPr wrap="square" lIns="0" tIns="0" rIns="0" bIns="0" rtlCol="0" anchor="ctr"/>
-          <a:lstStyle/>
-          <a:p>
-            <a:pPr indent="0" marL="0">
-              <a:buNone/>
-            </a:pPr>
-            <a:r>
-              <a:rPr lang="en-US" sz="1500" b="1" dirty="0">
-                <a:solidFill>
-                  <a:srgbClr val="1F6FEB"/>
-                </a:solidFill>
-                <a:latin typeface="Calibri" pitchFamily="34" charset="0"/>
-                <a:ea typeface="Calibri" pitchFamily="34" charset="-122"/>
-                <a:cs typeface="Calibri" pitchFamily="34" charset="-120"/>
-              </a:rPr>
-              <a:t>Why Go-Back-N?</a:t>
-            </a:r>
-            <a:endParaRPr lang="en-US" sz="1500" dirty="0"/>
-          </a:p>
-        </p:txBody>
-      </p:sp>
-      <p:sp>
-        <p:nvSpPr>
-          <p:cNvPr id="15" name="Text 13"/>
-          <p:cNvSpPr/>
-          <p:nvPr/>
-        </p:nvSpPr>
-        <p:spPr>
-          <a:xfrm>
-            <a:off x="640080" y="4754880"/>
-            <a:ext cx="10972800" cy="530352"/>
-          </a:xfrm>
-          <a:prstGeom prst="rect">
-            <a:avLst/>
-          </a:prstGeom>
-          <a:noFill/>
-          <a:ln/>
-        </p:spPr>
-        <p:txBody>
-          <a:bodyPr wrap="square" lIns="0" tIns="0" rIns="0" bIns="0" rtlCol="0" anchor="t"/>
-          <a:lstStyle/>
-          <a:p>
-            <a:pPr indent="0" marL="0">
-              <a:buNone/>
-            </a:pPr>
-            <a:r>
-              <a:rPr lang="en-US" sz="1350" dirty="0">
-                <a:solidFill>
-                  <a:srgbClr val="1B2430"/>
-                </a:solidFill>
-                <a:latin typeface="Calibri" pitchFamily="34" charset="0"/>
-                <a:ea typeface="Calibri" pitchFamily="34" charset="-122"/>
-                <a:cs typeface="Calibri" pitchFamily="34" charset="-120"/>
-              </a:rPr>
-              <a:t>We started with it because it is simple to build and explain, then replaced it as the default with Selective Repeat: the receiver buffers out-of-order packets and reports them in an ACK bitmap, and the sender resends only what is missing. Go-Back-N stays behind a flag for comparison.</a:t>
-            </a:r>
-            <a:endParaRPr lang="en-US" sz="1350" dirty="0"/>
-          </a:p>
-        </p:txBody>
-      </p:sp>
-      <p:sp>
-        <p:nvSpPr>
-          <p:cNvPr id="16" name="Shape 14"/>
-          <p:cNvSpPr/>
-          <p:nvPr/>
-        </p:nvSpPr>
-        <p:spPr>
-          <a:xfrm>
-            <a:off x="457200" y="5394960"/>
-            <a:ext cx="11274552" cy="914400"/>
-          </a:xfrm>
-          <a:prstGeom prst="rect">
-            <a:avLst/>
-          </a:prstGeom>
-          <a:solidFill>
-            <a:srgbClr val="F2F6FB"/>
-          </a:solidFill>
-          <a:ln w="9525">
-            <a:solidFill>
-              <a:srgbClr val="D5DEE9"/>
-            </a:solidFill>
-            <a:prstDash val="solid"/>
-          </a:ln>
-        </p:spPr>
-      </p:sp>
-      <p:sp>
-        <p:nvSpPr>
-          <p:cNvPr id="17" name="Text 15"/>
-          <p:cNvSpPr/>
-          <p:nvPr/>
-        </p:nvSpPr>
-        <p:spPr>
-          <a:xfrm>
-            <a:off x="640080" y="5440680"/>
-            <a:ext cx="10972800" cy="320040"/>
-          </a:xfrm>
-          <a:prstGeom prst="rect">
-            <a:avLst/>
-          </a:prstGeom>
-          <a:noFill/>
-          <a:ln/>
-        </p:spPr>
-        <p:txBody>
-          <a:bodyPr wrap="square" lIns="0" tIns="0" rIns="0" bIns="0" rtlCol="0" anchor="ctr"/>
-          <a:lstStyle/>
-          <a:p>
-            <a:pPr indent="0" marL="0">
-              <a:buNone/>
-            </a:pPr>
-            <a:r>
-              <a:rPr lang="en-US" sz="1500" b="1" dirty="0">
-                <a:solidFill>
-                  <a:srgbClr val="1F6FEB"/>
-                </a:solidFill>
-                <a:latin typeface="Calibri" pitchFamily="34" charset="0"/>
-                <a:ea typeface="Calibri" pitchFamily="34" charset="-122"/>
-                <a:cs typeface="Calibri" pitchFamily="34" charset="-120"/>
-              </a:rPr>
-              <a:t>Tests ran on one machine?</a:t>
-            </a:r>
-            <a:endParaRPr lang="en-US" sz="1500" dirty="0"/>
-          </a:p>
-        </p:txBody>
-      </p:sp>
-      <p:sp>
-        <p:nvSpPr>
-          <p:cNvPr id="18" name="Text 16"/>
-          <p:cNvSpPr/>
-          <p:nvPr/>
-        </p:nvSpPr>
-        <p:spPr>
-          <a:xfrm>
-            <a:off x="640080" y="5760720"/>
-            <a:ext cx="10972800" cy="530352"/>
-          </a:xfrm>
-          <a:prstGeom prst="rect">
-            <a:avLst/>
-          </a:prstGeom>
-          <a:noFill/>
-          <a:ln/>
-        </p:spPr>
-        <p:txBody>
-          <a:bodyPr wrap="square" lIns="0" tIns="0" rIns="0" bIns="0" rtlCol="0" anchor="t"/>
-          <a:lstStyle/>
-          <a:p>
-            <a:pPr indent="0" marL="0">
-              <a:buNone/>
-            </a:pPr>
-            <a:r>
-              <a:rPr lang="en-US" sz="1350" dirty="0">
-                <a:solidFill>
-                  <a:srgbClr val="1B2430"/>
-                </a:solidFill>
-                <a:latin typeface="Calibri" pitchFamily="34" charset="0"/>
-                <a:ea typeface="Calibri" pitchFamily="34" charset="-122"/>
-                <a:cs typeface="Calibri" pitchFamily="34" charset="-120"/>
-              </a:rPr>
-              <a:t>Yes. Delay, loss and jitter are emulated in our client, in a separate proxy on real UDP sockets, and in virtual time; these agree with each other. We also ran it once on the Linux kernel with tc netem on one laptop: the agent beat tuned AIMD there, but kernel TCP was 1.5 to 1.7 times faster than us. No multi-machine path was tested.</a:t>
-            </a:r>
-            <a:endParaRPr lang="en-US" sz="1350" dirty="0"/>
+              <a:t>Pause and smile; hand over to questions.</a:t>
+            </a:r>
+            <a:endParaRPr lang="en-US" sz="1400" dirty="0"/>
           </a:p>
         </p:txBody>
       </p:sp>
@@ -25879,7 +26263,7 @@
                 <a:ea typeface="Calibri" pitchFamily="34" charset="-122"/>
                 <a:cs typeface="Calibri" pitchFamily="34" charset="-120"/>
               </a:rPr>
-              <a:t>Hard questions and short answers (2 of 3)</a:t>
+              <a:t>39. Appendix: slow start</a:t>
             </a:r>
             <a:endParaRPr lang="en-US" sz="2600" dirty="0"/>
           </a:p>
@@ -25887,7 +26271,46 @@
       </p:sp>
       <p:sp>
         <p:nvSpPr>
-          <p:cNvPr id="3" name="Shape 1"/>
+          <p:cNvPr id="3" name="Text 1"/>
+          <p:cNvSpPr/>
+          <p:nvPr/>
+        </p:nvSpPr>
+        <p:spPr>
+          <a:xfrm>
+            <a:off x="457200" y="804672"/>
+            <a:ext cx="10972800" cy="320040"/>
+          </a:xfrm>
+          <a:prstGeom prst="rect">
+            <a:avLst/>
+          </a:prstGeom>
+          <a:noFill/>
+          <a:ln/>
+        </p:spPr>
+        <p:txBody>
+          <a:bodyPr wrap="square" lIns="0" tIns="0" rIns="0" bIns="0" rtlCol="0" anchor="ctr"/>
+          <a:lstStyle/>
+          <a:p>
+            <a:pPr indent="0" marL="0">
+              <a:buNone/>
+            </a:pPr>
+            <a:r>
+              <a:rPr lang="en-US" sz="1300" dirty="0">
+                <a:solidFill>
+                  <a:srgbClr val="5B6775"/>
+                </a:solidFill>
+                <a:latin typeface="Calibri" pitchFamily="34" charset="0"/>
+                <a:ea typeface="Calibri" pitchFamily="34" charset="-122"/>
+                <a:cs typeface="Calibri" pitchFamily="34" charset="-120"/>
+              </a:rPr>
+              <a:t>Time on this slide: -</a:t>
+            </a:r>
+            <a:endParaRPr lang="en-US" sz="1300" dirty="0"/>
+          </a:p>
+        </p:txBody>
+      </p:sp>
+      <p:sp>
+        <p:nvSpPr>
+          <p:cNvPr id="4" name="Shape 2"/>
           <p:cNvSpPr/>
           <p:nvPr/>
         </p:nvSpPr>
@@ -25910,26 +26333,47 @@
           </a:ln>
         </p:spPr>
       </p:sp>
-      <p:sp>
-        <p:nvSpPr>
-          <p:cNvPr id="4" name="Shape 2"/>
-          <p:cNvSpPr/>
-          <p:nvPr/>
-        </p:nvSpPr>
+      <p:pic>
+        <p:nvPicPr>
+          <p:cNvPr id="5" name="Image 0" descr="th-39.png">    </p:cNvPr>
+          <p:cNvPicPr>
+            <a:picLocks noChangeAspect="1"/>
+          </p:cNvPicPr>
+          <p:nvPr/>
+        </p:nvPicPr>
+        <p:blipFill>
+          <a:blip r:embed="rId1"/>
+          <a:stretch>
+            <a:fillRect/>
+          </a:stretch>
+        </p:blipFill>
         <p:spPr>
           <a:xfrm>
             <a:off x="457200" y="1371600"/>
-            <a:ext cx="11274552" cy="914400"/>
-          </a:xfrm>
-          <a:prstGeom prst="rect">
-            <a:avLst/>
-          </a:prstGeom>
-          <a:solidFill>
-            <a:srgbClr val="F2F6FB"/>
-          </a:solidFill>
-          <a:ln w="9525">
+            <a:ext cx="5669280" cy="3188970"/>
+          </a:xfrm>
+          <a:prstGeom prst="rect">
+            <a:avLst/>
+          </a:prstGeom>
+        </p:spPr>
+      </p:pic>
+      <p:sp>
+        <p:nvSpPr>
+          <p:cNvPr id="6" name="Shape 3"/>
+          <p:cNvSpPr/>
+          <p:nvPr/>
+        </p:nvSpPr>
+        <p:spPr>
+          <a:xfrm>
+            <a:off x="457200" y="1371600"/>
+            <a:ext cx="5669280" cy="3188970"/>
+          </a:xfrm>
+          <a:prstGeom prst="rect">
+            <a:avLst/>
+          </a:prstGeom>
+          <a:ln w="12700">
             <a:solidFill>
-              <a:srgbClr val="D5DEE9"/>
+              <a:srgbClr val="C9D3E0"/>
             </a:solidFill>
             <a:prstDash val="solid"/>
           </a:ln>
@@ -25937,14 +26381,14 @@
       </p:sp>
       <p:sp>
         <p:nvSpPr>
-          <p:cNvPr id="5" name="Text 3"/>
-          <p:cNvSpPr/>
-          <p:nvPr/>
-        </p:nvSpPr>
-        <p:spPr>
-          <a:xfrm>
-            <a:off x="640080" y="1417320"/>
-            <a:ext cx="10972800" cy="320040"/>
+          <p:cNvPr id="7" name="Text 4"/>
+          <p:cNvSpPr/>
+          <p:nvPr/>
+        </p:nvSpPr>
+        <p:spPr>
+          <a:xfrm>
+            <a:off x="6400800" y="1325880"/>
+            <a:ext cx="1828800" cy="320040"/>
           </a:xfrm>
           <a:prstGeom prst="rect">
             <a:avLst/>
@@ -25960,7 +26404,7 @@
               <a:buNone/>
             </a:pPr>
             <a:r>
-              <a:rPr lang="en-US" sz="1500" b="1" dirty="0">
+              <a:rPr lang="en-US" sz="1300" b="1" dirty="0">
                 <a:solidFill>
                   <a:srgbClr val="1F6FEB"/>
                 </a:solidFill>
@@ -25968,22 +26412,22 @@
                 <a:ea typeface="Calibri" pitchFamily="34" charset="-122"/>
                 <a:cs typeface="Calibri" pitchFamily="34" charset="-120"/>
               </a:rPr>
-              <a:t>What does Packet Tracer prove?</a:t>
-            </a:r>
-            <a:endParaRPr lang="en-US" sz="1500" dirty="0"/>
-          </a:p>
-        </p:txBody>
-      </p:sp>
-      <p:sp>
-        <p:nvSpPr>
-          <p:cNvPr id="6" name="Text 4"/>
-          <p:cNvSpPr/>
-          <p:nvPr/>
-        </p:nvSpPr>
-        <p:spPr>
-          <a:xfrm>
-            <a:off x="640080" y="1737360"/>
-            <a:ext cx="10972800" cy="530352"/>
+              <a:t>SAY</a:t>
+            </a:r>
+            <a:endParaRPr lang="en-US" sz="1300" dirty="0"/>
+          </a:p>
+        </p:txBody>
+      </p:sp>
+      <p:sp>
+        <p:nvSpPr>
+          <p:cNvPr id="8" name="Text 5"/>
+          <p:cNvSpPr/>
+          <p:nvPr/>
+        </p:nvSpPr>
+        <p:spPr>
+          <a:xfrm>
+            <a:off x="6400800" y="1645920"/>
+            <a:ext cx="5349240" cy="3017520"/>
           </a:xfrm>
           <a:prstGeom prst="rect">
             <a:avLst/>
@@ -25995,11 +26439,15 @@
           <a:bodyPr wrap="square" lIns="0" tIns="0" rIns="0" bIns="0" rtlCol="0" anchor="t"/>
           <a:lstStyle/>
           <a:p>
-            <a:pPr indent="0" marL="0">
-              <a:buNone/>
-            </a:pPr>
-            <a:r>
-              <a:rPr lang="en-US" sz="1350" dirty="0">
+            <a:pPr marL="342900" indent="-342900">
+              <a:spcAft>
+                <a:spcPts val="600"/>
+              </a:spcAft>
+              <a:buSzPct val="100000"/>
+              <a:buChar char="•"/>
+            </a:pPr>
+            <a:r>
+              <a:rPr lang="en-US" sz="1600" dirty="0">
                 <a:solidFill>
                   <a:srgbClr val="1B2430"/>
                 </a:solidFill>
@@ -26007,32 +26455,32 @@
                 <a:ea typeface="Calibri" pitchFamily="34" charset="-122"/>
                 <a:cs typeface="Calibri" pitchFamily="34" charset="-120"/>
               </a:rPr>
-              <a:t>The network design: OSPF, VLANs, ACL, 70/71 failover. The protocol is validated separately with emulation and Wireshark.</a:t>
-            </a:r>
-            <a:endParaRPr lang="en-US" sz="1350" dirty="0"/>
-          </a:p>
-        </p:txBody>
-      </p:sp>
-      <p:sp>
-        <p:nvSpPr>
-          <p:cNvPr id="7" name="Shape 5"/>
-          <p:cNvSpPr/>
-          <p:nvPr/>
-        </p:nvSpPr>
-        <p:spPr>
-          <a:xfrm>
-            <a:off x="457200" y="2377440"/>
-            <a:ext cx="11274552" cy="914400"/>
+              <a:t>Only if asked: the window starts at 1, adds 1 per ACK until the threshold 16, then 1/window per ACK. In the 62-packet run the final window was 18.71.</a:t>
+            </a:r>
+            <a:endParaRPr lang="en-US" sz="1600" dirty="0"/>
+          </a:p>
+        </p:txBody>
+      </p:sp>
+      <p:sp>
+        <p:nvSpPr>
+          <p:cNvPr id="9" name="Shape 6"/>
+          <p:cNvSpPr/>
+          <p:nvPr/>
+        </p:nvSpPr>
+        <p:spPr>
+          <a:xfrm>
+            <a:off x="457200" y="4709160"/>
+            <a:ext cx="5669280" cy="1737360"/>
           </a:xfrm>
           <a:prstGeom prst="rect">
             <a:avLst/>
           </a:prstGeom>
           <a:solidFill>
-            <a:srgbClr val="F2F6FB"/>
+            <a:srgbClr val="FFF6E5"/>
           </a:solidFill>
-          <a:ln w="9525">
+          <a:ln w="12700">
             <a:solidFill>
-              <a:srgbClr val="D5DEE9"/>
+              <a:srgbClr val="F0C987"/>
             </a:solidFill>
             <a:prstDash val="solid"/>
           </a:ln>
@@ -26040,14 +26488,14 @@
       </p:sp>
       <p:sp>
         <p:nvSpPr>
-          <p:cNvPr id="8" name="Text 6"/>
-          <p:cNvSpPr/>
-          <p:nvPr/>
-        </p:nvSpPr>
-        <p:spPr>
-          <a:xfrm>
-            <a:off x="640080" y="2423160"/>
-            <a:ext cx="10972800" cy="320040"/>
+          <p:cNvPr id="10" name="Text 7"/>
+          <p:cNvSpPr/>
+          <p:nvPr/>
+        </p:nvSpPr>
+        <p:spPr>
+          <a:xfrm>
+            <a:off x="594360" y="4754880"/>
+            <a:ext cx="5394960" cy="1645920"/>
           </a:xfrm>
           <a:prstGeom prst="rect">
             <a:avLst/>
@@ -26056,53 +26504,28 @@
           <a:ln/>
         </p:spPr>
         <p:txBody>
-          <a:bodyPr wrap="square" lIns="0" tIns="0" rIns="0" bIns="0" rtlCol="0" anchor="ctr"/>
+          <a:bodyPr wrap="square" lIns="0" tIns="0" rIns="0" bIns="0" rtlCol="0" anchor="t"/>
           <a:lstStyle/>
           <a:p>
             <a:pPr indent="0" marL="0">
               <a:buNone/>
             </a:pPr>
             <a:r>
-              <a:rPr lang="en-US" sz="1500" b="1" dirty="0">
-                <a:solidFill>
-                  <a:srgbClr val="1F6FEB"/>
-                </a:solidFill>
-                <a:latin typeface="Calibri" pitchFamily="34" charset="0"/>
-                <a:ea typeface="Calibri" pitchFamily="34" charset="-122"/>
-                <a:cs typeface="Calibri" pitchFamily="34" charset="-120"/>
-              </a:rPr>
-              <a:t>Peer disappears?</a:t>
-            </a:r>
-            <a:endParaRPr lang="en-US" sz="1500" dirty="0"/>
-          </a:p>
-        </p:txBody>
-      </p:sp>
-      <p:sp>
-        <p:nvSpPr>
-          <p:cNvPr id="9" name="Text 7"/>
-          <p:cNvSpPr/>
-          <p:nvPr/>
-        </p:nvSpPr>
-        <p:spPr>
-          <a:xfrm>
-            <a:off x="640080" y="2743200"/>
-            <a:ext cx="10972800" cy="530352"/>
-          </a:xfrm>
-          <a:prstGeom prst="rect">
-            <a:avLst/>
-          </a:prstGeom>
-          <a:noFill/>
-          <a:ln/>
-        </p:spPr>
-        <p:txBody>
-          <a:bodyPr wrap="square" lIns="0" tIns="0" rIns="0" bIns="0" rtlCol="0" anchor="t"/>
-          <a:lstStyle/>
-          <a:p>
+              <a:rPr lang="en-US" sz="1400" b="1" dirty="0">
+                <a:solidFill>
+                  <a:srgbClr val="B45309"/>
+                </a:solidFill>
+                <a:latin typeface="Calibri" pitchFamily="34" charset="0"/>
+                <a:ea typeface="Calibri" pitchFamily="34" charset="-122"/>
+                <a:cs typeface="Calibri" pitchFamily="34" charset="-120"/>
+              </a:rPr>
+              <a:t>IF ASKED  </a:t>
+            </a:r>
             <a:pPr indent="0" marL="0">
               <a:buNone/>
             </a:pPr>
             <a:r>
-              <a:rPr lang="en-US" sz="1350" dirty="0">
+              <a:rPr lang="en-US" sz="1400" dirty="0">
                 <a:solidFill>
                   <a:srgbClr val="1B2430"/>
                 </a:solidFill>
@@ -26110,318 +26533,9 @@
                 <a:ea typeface="Calibri" pitchFamily="34" charset="-122"/>
                 <a:cs typeface="Calibri" pitchFamily="34" charset="-120"/>
               </a:rPr>
-              <a:t>Sender keeps retransmitting on timeout. A connection abort after repeated timeouts is not built; it is the fix we would add.</a:t>
-            </a:r>
-            <a:endParaRPr lang="en-US" sz="1350" dirty="0"/>
-          </a:p>
-        </p:txBody>
-      </p:sp>
-      <p:sp>
-        <p:nvSpPr>
-          <p:cNvPr id="10" name="Shape 8"/>
-          <p:cNvSpPr/>
-          <p:nvPr/>
-        </p:nvSpPr>
-        <p:spPr>
-          <a:xfrm>
-            <a:off x="457200" y="3383280"/>
-            <a:ext cx="11274552" cy="914400"/>
-          </a:xfrm>
-          <a:prstGeom prst="rect">
-            <a:avLst/>
-          </a:prstGeom>
-          <a:solidFill>
-            <a:srgbClr val="F2F6FB"/>
-          </a:solidFill>
-          <a:ln w="9525">
-            <a:solidFill>
-              <a:srgbClr val="D5DEE9"/>
-            </a:solidFill>
-            <a:prstDash val="solid"/>
-          </a:ln>
-        </p:spPr>
-      </p:sp>
-      <p:sp>
-        <p:nvSpPr>
-          <p:cNvPr id="11" name="Text 9"/>
-          <p:cNvSpPr/>
-          <p:nvPr/>
-        </p:nvSpPr>
-        <p:spPr>
-          <a:xfrm>
-            <a:off x="640080" y="3429000"/>
-            <a:ext cx="10972800" cy="320040"/>
-          </a:xfrm>
-          <a:prstGeom prst="rect">
-            <a:avLst/>
-          </a:prstGeom>
-          <a:noFill/>
-          <a:ln/>
-        </p:spPr>
-        <p:txBody>
-          <a:bodyPr wrap="square" lIns="0" tIns="0" rIns="0" bIns="0" rtlCol="0" anchor="ctr"/>
-          <a:lstStyle/>
-          <a:p>
-            <a:pPr indent="0" marL="0">
-              <a:buNone/>
-            </a:pPr>
-            <a:r>
-              <a:rPr lang="en-US" sz="1500" b="1" dirty="0">
-                <a:solidFill>
-                  <a:srgbClr val="1F6FEB"/>
-                </a:solidFill>
-                <a:latin typeface="Calibri" pitchFamily="34" charset="0"/>
-                <a:ea typeface="Calibri" pitchFamily="34" charset="-122"/>
-                <a:cs typeface="Calibri" pitchFamily="34" charset="-120"/>
-              </a:rPr>
-              <a:t>Does the checksum catch errors?</a:t>
-            </a:r>
-            <a:endParaRPr lang="en-US" sz="1500" dirty="0"/>
-          </a:p>
-        </p:txBody>
-      </p:sp>
-      <p:sp>
-        <p:nvSpPr>
-          <p:cNvPr id="12" name="Text 10"/>
-          <p:cNvSpPr/>
-          <p:nvPr/>
-        </p:nvSpPr>
-        <p:spPr>
-          <a:xfrm>
-            <a:off x="640080" y="3749040"/>
-            <a:ext cx="10972800" cy="530352"/>
-          </a:xfrm>
-          <a:prstGeom prst="rect">
-            <a:avLst/>
-          </a:prstGeom>
-          <a:noFill/>
-          <a:ln/>
-        </p:spPr>
-        <p:txBody>
-          <a:bodyPr wrap="square" lIns="0" tIns="0" rIns="0" bIns="0" rtlCol="0" anchor="t"/>
-          <a:lstStyle/>
-          <a:p>
-            <a:pPr indent="0" marL="0">
-              <a:buNone/>
-            </a:pPr>
-            <a:r>
-              <a:rPr lang="en-US" sz="1350" dirty="0">
-                <a:solidFill>
-                  <a:srgbClr val="1B2430"/>
-                </a:solidFill>
-                <a:latin typeface="Calibri" pitchFamily="34" charset="0"/>
-                <a:ea typeface="Calibri" pitchFamily="34" charset="-122"/>
-                <a:cs typeface="Calibri" pitchFamily="34" charset="-120"/>
-              </a:rPr>
-              <a:t>It is CRC-16/CCITT now. The first version was a byte sum and a fuzzer showed 2 percent of corrupted packets got through; with CRC-16 none of 333,000 did. It cannot catch every error pattern, as no 16-bit check can.</a:t>
-            </a:r>
-            <a:endParaRPr lang="en-US" sz="1350" dirty="0"/>
-          </a:p>
-        </p:txBody>
-      </p:sp>
-      <p:sp>
-        <p:nvSpPr>
-          <p:cNvPr id="13" name="Shape 11"/>
-          <p:cNvSpPr/>
-          <p:nvPr/>
-        </p:nvSpPr>
-        <p:spPr>
-          <a:xfrm>
-            <a:off x="457200" y="4389120"/>
-            <a:ext cx="11274552" cy="914400"/>
-          </a:xfrm>
-          <a:prstGeom prst="rect">
-            <a:avLst/>
-          </a:prstGeom>
-          <a:solidFill>
-            <a:srgbClr val="F2F6FB"/>
-          </a:solidFill>
-          <a:ln w="9525">
-            <a:solidFill>
-              <a:srgbClr val="D5DEE9"/>
-            </a:solidFill>
-            <a:prstDash val="solid"/>
-          </a:ln>
-        </p:spPr>
-      </p:sp>
-      <p:sp>
-        <p:nvSpPr>
-          <p:cNvPr id="14" name="Text 12"/>
-          <p:cNvSpPr/>
-          <p:nvPr/>
-        </p:nvSpPr>
-        <p:spPr>
-          <a:xfrm>
-            <a:off x="640080" y="4434840"/>
-            <a:ext cx="10972800" cy="320040"/>
-          </a:xfrm>
-          <a:prstGeom prst="rect">
-            <a:avLst/>
-          </a:prstGeom>
-          <a:noFill/>
-          <a:ln/>
-        </p:spPr>
-        <p:txBody>
-          <a:bodyPr wrap="square" lIns="0" tIns="0" rIns="0" bIns="0" rtlCol="0" anchor="ctr"/>
-          <a:lstStyle/>
-          <a:p>
-            <a:pPr indent="0" marL="0">
-              <a:buNone/>
-            </a:pPr>
-            <a:r>
-              <a:rPr lang="en-US" sz="1500" b="1" dirty="0">
-                <a:solidFill>
-                  <a:srgbClr val="1F6FEB"/>
-                </a:solidFill>
-                <a:latin typeface="Calibri" pitchFamily="34" charset="0"/>
-                <a:ea typeface="Calibri" pitchFamily="34" charset="-122"/>
-                <a:cs typeface="Calibri" pitchFamily="34" charset="-120"/>
-              </a:rPr>
-              <a:t>Why no handshake in the exported trace?</a:t>
-            </a:r>
-            <a:endParaRPr lang="en-US" sz="1500" dirty="0"/>
-          </a:p>
-        </p:txBody>
-      </p:sp>
-      <p:sp>
-        <p:nvSpPr>
-          <p:cNvPr id="15" name="Text 13"/>
-          <p:cNvSpPr/>
-          <p:nvPr/>
-        </p:nvSpPr>
-        <p:spPr>
-          <a:xfrm>
-            <a:off x="640080" y="4754880"/>
-            <a:ext cx="10972800" cy="530352"/>
-          </a:xfrm>
-          <a:prstGeom prst="rect">
-            <a:avLst/>
-          </a:prstGeom>
-          <a:noFill/>
-          <a:ln/>
-        </p:spPr>
-        <p:txBody>
-          <a:bodyPr wrap="square" lIns="0" tIns="0" rIns="0" bIns="0" rtlCol="0" anchor="t"/>
-          <a:lstStyle/>
-          <a:p>
-            <a:pPr indent="0" marL="0">
-              <a:buNone/>
-            </a:pPr>
-            <a:r>
-              <a:rPr lang="en-US" sz="1350" dirty="0">
-                <a:solidFill>
-                  <a:srgbClr val="1B2430"/>
-                </a:solidFill>
-                <a:latin typeface="Calibri" pitchFamily="34" charset="0"/>
-                <a:ea typeface="Calibri" pitchFamily="34" charset="-122"/>
-                <a:cs typeface="Calibri" pitchFamily="34" charset="-120"/>
-              </a:rPr>
-              <a:t>The export builds synthetic packets. The real tshark capture shows SYN, SYN-ACK, ACK.</a:t>
-            </a:r>
-            <a:endParaRPr lang="en-US" sz="1350" dirty="0"/>
-          </a:p>
-        </p:txBody>
-      </p:sp>
-      <p:sp>
-        <p:nvSpPr>
-          <p:cNvPr id="16" name="Shape 14"/>
-          <p:cNvSpPr/>
-          <p:nvPr/>
-        </p:nvSpPr>
-        <p:spPr>
-          <a:xfrm>
-            <a:off x="457200" y="5394960"/>
-            <a:ext cx="11274552" cy="914400"/>
-          </a:xfrm>
-          <a:prstGeom prst="rect">
-            <a:avLst/>
-          </a:prstGeom>
-          <a:solidFill>
-            <a:srgbClr val="F2F6FB"/>
-          </a:solidFill>
-          <a:ln w="9525">
-            <a:solidFill>
-              <a:srgbClr val="D5DEE9"/>
-            </a:solidFill>
-            <a:prstDash val="solid"/>
-          </a:ln>
-        </p:spPr>
-      </p:sp>
-      <p:sp>
-        <p:nvSpPr>
-          <p:cNvPr id="17" name="Text 15"/>
-          <p:cNvSpPr/>
-          <p:nvPr/>
-        </p:nvSpPr>
-        <p:spPr>
-          <a:xfrm>
-            <a:off x="640080" y="5440680"/>
-            <a:ext cx="10972800" cy="320040"/>
-          </a:xfrm>
-          <a:prstGeom prst="rect">
-            <a:avLst/>
-          </a:prstGeom>
-          <a:noFill/>
-          <a:ln/>
-        </p:spPr>
-        <p:txBody>
-          <a:bodyPr wrap="square" lIns="0" tIns="0" rIns="0" bIns="0" rtlCol="0" anchor="ctr"/>
-          <a:lstStyle/>
-          <a:p>
-            <a:pPr indent="0" marL="0">
-              <a:buNone/>
-            </a:pPr>
-            <a:r>
-              <a:rPr lang="en-US" sz="1500" b="1" dirty="0">
-                <a:solidFill>
-                  <a:srgbClr val="1F6FEB"/>
-                </a:solidFill>
-                <a:latin typeface="Calibri" pitchFamily="34" charset="0"/>
-                <a:ea typeface="Calibri" pitchFamily="34" charset="-122"/>
-                <a:cs typeface="Calibri" pitchFamily="34" charset="-120"/>
-              </a:rPr>
-              <a:t>Is the baseline fair?</a:t>
-            </a:r>
-            <a:endParaRPr lang="en-US" sz="1500" dirty="0"/>
-          </a:p>
-        </p:txBody>
-      </p:sp>
-      <p:sp>
-        <p:nvSpPr>
-          <p:cNvPr id="18" name="Text 16"/>
-          <p:cNvSpPr/>
-          <p:nvPr/>
-        </p:nvSpPr>
-        <p:spPr>
-          <a:xfrm>
-            <a:off x="640080" y="5760720"/>
-            <a:ext cx="10972800" cy="530352"/>
-          </a:xfrm>
-          <a:prstGeom prst="rect">
-            <a:avLst/>
-          </a:prstGeom>
-          <a:noFill/>
-          <a:ln/>
-        </p:spPr>
-        <p:txBody>
-          <a:bodyPr wrap="square" lIns="0" tIns="0" rIns="0" bIns="0" rtlCol="0" anchor="t"/>
-          <a:lstStyle/>
-          <a:p>
-            <a:pPr indent="0" marL="0">
-              <a:buNone/>
-            </a:pPr>
-            <a:r>
-              <a:rPr lang="en-US" sz="1350" dirty="0">
-                <a:solidFill>
-                  <a:srgbClr val="1B2430"/>
-                </a:solidFill>
-                <a:latin typeface="Calibri" pitchFamily="34" charset="0"/>
-                <a:ea typeface="Calibri" pitchFamily="34" charset="-122"/>
-                <a:cs typeface="Calibri" pitchFamily="34" charset="-120"/>
-              </a:rPr>
-              <a:t>We tuned it: window cap 128 and a high start threshold, plus the same retransmission-timer floor for every policy. We also compare against tuned CUBIC. Tuned AIMD improved a lot, and the agent is still ahead on four paths.</a:t>
-            </a:r>
-            <a:endParaRPr lang="en-US" sz="1350" dirty="0"/>
+              <a:t>Use this slide to answer 'show me congestion avoidance'.</a:t>
+            </a:r>
+            <a:endParaRPr lang="en-US" sz="1400" dirty="0"/>
           </a:p>
         </p:txBody>
       </p:sp>
@@ -26436,6 +26550,1228 @@
 <file path=ppt/slides/slide42.xml><?xml version="1.0" encoding="utf-8"?>
 <p:sld xmlns:a="http://schemas.openxmlformats.org/drawingml/2006/main" xmlns:r="http://schemas.openxmlformats.org/officeDocument/2006/relationships" xmlns:p="http://schemas.openxmlformats.org/presentationml/2006/main">
   <p:cSld name="Slide 42">
+    <p:bg>
+      <p:bgPr>
+        <a:solidFill>
+          <a:srgbClr val="FFFFFF"/>
+        </a:solidFill>
+      </p:bgPr>
+    </p:bg>
+    <p:spTree>
+      <p:nvGrpSpPr>
+        <p:cNvPr id="1" name=""/>
+        <p:cNvGrpSpPr/>
+        <p:nvPr/>
+      </p:nvGrpSpPr>
+      <p:grpSpPr>
+        <a:xfrm>
+          <a:off x="0" y="0"/>
+          <a:ext cx="0" cy="0"/>
+          <a:chOff x="0" y="0"/>
+          <a:chExt cx="0" cy="0"/>
+        </a:xfrm>
+      </p:grpSpPr>
+      <p:sp>
+        <p:nvSpPr>
+          <p:cNvPr id="2" name="Text 0"/>
+          <p:cNvSpPr/>
+          <p:nvPr/>
+        </p:nvSpPr>
+        <p:spPr>
+          <a:xfrm>
+            <a:off x="457200" y="274320"/>
+            <a:ext cx="9601200" cy="548640"/>
+          </a:xfrm>
+          <a:prstGeom prst="rect">
+            <a:avLst/>
+          </a:prstGeom>
+          <a:noFill/>
+          <a:ln/>
+        </p:spPr>
+        <p:txBody>
+          <a:bodyPr wrap="square" lIns="0" tIns="0" rIns="0" bIns="0" rtlCol="0" anchor="ctr"/>
+          <a:lstStyle/>
+          <a:p>
+            <a:pPr indent="0" marL="0">
+              <a:buNone/>
+            </a:pPr>
+            <a:r>
+              <a:rPr lang="en-US" sz="2600" b="1" dirty="0">
+                <a:solidFill>
+                  <a:srgbClr val="1B2430"/>
+                </a:solidFill>
+                <a:latin typeface="Calibri" pitchFamily="34" charset="0"/>
+                <a:ea typeface="Calibri" pitchFamily="34" charset="-122"/>
+                <a:cs typeface="Calibri" pitchFamily="34" charset="-120"/>
+              </a:rPr>
+              <a:t>Hard questions and short answers (1 of 3)</a:t>
+            </a:r>
+            <a:endParaRPr lang="en-US" sz="2600" dirty="0"/>
+          </a:p>
+        </p:txBody>
+      </p:sp>
+      <p:sp>
+        <p:nvSpPr>
+          <p:cNvPr id="3" name="Shape 1"/>
+          <p:cNvSpPr/>
+          <p:nvPr/>
+        </p:nvSpPr>
+        <p:spPr>
+          <a:xfrm>
+            <a:off x="457200" y="1143000"/>
+            <a:ext cx="11274552" cy="36576"/>
+          </a:xfrm>
+          <a:prstGeom prst="rect">
+            <a:avLst/>
+          </a:prstGeom>
+          <a:solidFill>
+            <a:srgbClr val="1F6FEB"/>
+          </a:solidFill>
+          <a:ln w="12700">
+            <a:solidFill>
+              <a:srgbClr val="1F6FEB"/>
+            </a:solidFill>
+            <a:prstDash val="solid"/>
+          </a:ln>
+        </p:spPr>
+      </p:sp>
+      <p:sp>
+        <p:nvSpPr>
+          <p:cNvPr id="4" name="Shape 2"/>
+          <p:cNvSpPr/>
+          <p:nvPr/>
+        </p:nvSpPr>
+        <p:spPr>
+          <a:xfrm>
+            <a:off x="457200" y="1371600"/>
+            <a:ext cx="11274552" cy="914400"/>
+          </a:xfrm>
+          <a:prstGeom prst="rect">
+            <a:avLst/>
+          </a:prstGeom>
+          <a:solidFill>
+            <a:srgbClr val="F2F6FB"/>
+          </a:solidFill>
+          <a:ln w="9525">
+            <a:solidFill>
+              <a:srgbClr val="D5DEE9"/>
+            </a:solidFill>
+            <a:prstDash val="solid"/>
+          </a:ln>
+        </p:spPr>
+      </p:sp>
+      <p:sp>
+        <p:nvSpPr>
+          <p:cNvPr id="5" name="Text 3"/>
+          <p:cNvSpPr/>
+          <p:nvPr/>
+        </p:nvSpPr>
+        <p:spPr>
+          <a:xfrm>
+            <a:off x="640080" y="1417320"/>
+            <a:ext cx="10972800" cy="320040"/>
+          </a:xfrm>
+          <a:prstGeom prst="rect">
+            <a:avLst/>
+          </a:prstGeom>
+          <a:noFill/>
+          <a:ln/>
+        </p:spPr>
+        <p:txBody>
+          <a:bodyPr wrap="square" lIns="0" tIns="0" rIns="0" bIns="0" rtlCol="0" anchor="ctr"/>
+          <a:lstStyle/>
+          <a:p>
+            <a:pPr indent="0" marL="0">
+              <a:buNone/>
+            </a:pPr>
+            <a:r>
+              <a:rPr lang="en-US" sz="1500" b="1" dirty="0">
+                <a:solidFill>
+                  <a:srgbClr val="1F6FEB"/>
+                </a:solidFill>
+                <a:latin typeface="Calibri" pitchFamily="34" charset="0"/>
+                <a:ea typeface="Calibri" pitchFamily="34" charset="-122"/>
+                <a:cs typeface="Calibri" pitchFamily="34" charset="-120"/>
+              </a:rPr>
+              <a:t>Is this a lab exercise?</a:t>
+            </a:r>
+            <a:endParaRPr lang="en-US" sz="1500" dirty="0"/>
+          </a:p>
+        </p:txBody>
+      </p:sp>
+      <p:sp>
+        <p:nvSpPr>
+          <p:cNvPr id="6" name="Text 4"/>
+          <p:cNvSpPr/>
+          <p:nvPr/>
+        </p:nvSpPr>
+        <p:spPr>
+          <a:xfrm>
+            <a:off x="640080" y="1737360"/>
+            <a:ext cx="10972800" cy="530352"/>
+          </a:xfrm>
+          <a:prstGeom prst="rect">
+            <a:avLst/>
+          </a:prstGeom>
+          <a:noFill/>
+          <a:ln/>
+        </p:spPr>
+        <p:txBody>
+          <a:bodyPr wrap="square" lIns="0" tIns="0" rIns="0" bIns="0" rtlCol="0" anchor="t"/>
+          <a:lstStyle/>
+          <a:p>
+            <a:pPr indent="0" marL="0">
+              <a:buNone/>
+            </a:pPr>
+            <a:r>
+              <a:rPr lang="en-US" sz="1350" dirty="0">
+                <a:solidFill>
+                  <a:srgbClr val="1B2430"/>
+                </a:solidFill>
+                <a:latin typeface="Calibri" pitchFamily="34" charset="0"/>
+                <a:ea typeface="Calibri" pitchFamily="34" charset="-122"/>
+                <a:cs typeface="Calibri" pitchFamily="34" charset="-120"/>
+              </a:rPr>
+              <a:t>A lab sends datagrams. We built reliability and congestion control on top, measured them, and used them in a real chat and a routed network.</a:t>
+            </a:r>
+            <a:endParaRPr lang="en-US" sz="1350" dirty="0"/>
+          </a:p>
+        </p:txBody>
+      </p:sp>
+      <p:sp>
+        <p:nvSpPr>
+          <p:cNvPr id="7" name="Shape 5"/>
+          <p:cNvSpPr/>
+          <p:nvPr/>
+        </p:nvSpPr>
+        <p:spPr>
+          <a:xfrm>
+            <a:off x="457200" y="2377440"/>
+            <a:ext cx="11274552" cy="914400"/>
+          </a:xfrm>
+          <a:prstGeom prst="rect">
+            <a:avLst/>
+          </a:prstGeom>
+          <a:solidFill>
+            <a:srgbClr val="F2F6FB"/>
+          </a:solidFill>
+          <a:ln w="9525">
+            <a:solidFill>
+              <a:srgbClr val="D5DEE9"/>
+            </a:solidFill>
+            <a:prstDash val="solid"/>
+          </a:ln>
+        </p:spPr>
+      </p:sp>
+      <p:sp>
+        <p:nvSpPr>
+          <p:cNvPr id="8" name="Text 6"/>
+          <p:cNvSpPr/>
+          <p:nvPr/>
+        </p:nvSpPr>
+        <p:spPr>
+          <a:xfrm>
+            <a:off x="640080" y="2423160"/>
+            <a:ext cx="10972800" cy="320040"/>
+          </a:xfrm>
+          <a:prstGeom prst="rect">
+            <a:avLst/>
+          </a:prstGeom>
+          <a:noFill/>
+          <a:ln/>
+        </p:spPr>
+        <p:txBody>
+          <a:bodyPr wrap="square" lIns="0" tIns="0" rIns="0" bIns="0" rtlCol="0" anchor="ctr"/>
+          <a:lstStyle/>
+          <a:p>
+            <a:pPr indent="0" marL="0">
+              <a:buNone/>
+            </a:pPr>
+            <a:r>
+              <a:rPr lang="en-US" sz="1500" b="1" dirty="0">
+                <a:solidFill>
+                  <a:srgbClr val="1F6FEB"/>
+                </a:solidFill>
+                <a:latin typeface="Calibri" pitchFamily="34" charset="0"/>
+                <a:ea typeface="Calibri" pitchFamily="34" charset="-122"/>
+                <a:cs typeface="Calibri" pitchFamily="34" charset="-120"/>
+              </a:rPr>
+              <a:t>Why not TCP?</a:t>
+            </a:r>
+            <a:endParaRPr lang="en-US" sz="1500" dirty="0"/>
+          </a:p>
+        </p:txBody>
+      </p:sp>
+      <p:sp>
+        <p:nvSpPr>
+          <p:cNvPr id="9" name="Text 7"/>
+          <p:cNvSpPr/>
+          <p:nvPr/>
+        </p:nvSpPr>
+        <p:spPr>
+          <a:xfrm>
+            <a:off x="640080" y="2743200"/>
+            <a:ext cx="10972800" cy="530352"/>
+          </a:xfrm>
+          <a:prstGeom prst="rect">
+            <a:avLst/>
+          </a:prstGeom>
+          <a:noFill/>
+          <a:ln/>
+        </p:spPr>
+        <p:txBody>
+          <a:bodyPr wrap="square" lIns="0" tIns="0" rIns="0" bIns="0" rtlCol="0" anchor="t"/>
+          <a:lstStyle/>
+          <a:p>
+            <a:pPr indent="0" marL="0">
+              <a:buNone/>
+            </a:pPr>
+            <a:r>
+              <a:rPr lang="en-US" sz="1350" dirty="0">
+                <a:solidFill>
+                  <a:srgbClr val="1B2430"/>
+                </a:solidFill>
+                <a:latin typeface="Calibri" pitchFamily="34" charset="0"/>
+                <a:ea typeface="Calibri" pitchFamily="34" charset="-122"/>
+                <a:cs typeface="Calibri" pitchFamily="34" charset="-120"/>
+              </a:rPr>
+              <a:t>TCP is in the kernel and cannot be changed. Building our own makes every mechanism visible. QUIC and HTTP/3 do the same.</a:t>
+            </a:r>
+            <a:endParaRPr lang="en-US" sz="1350" dirty="0"/>
+          </a:p>
+        </p:txBody>
+      </p:sp>
+      <p:sp>
+        <p:nvSpPr>
+          <p:cNvPr id="10" name="Shape 8"/>
+          <p:cNvSpPr/>
+          <p:nvPr/>
+        </p:nvSpPr>
+        <p:spPr>
+          <a:xfrm>
+            <a:off x="457200" y="3383280"/>
+            <a:ext cx="11274552" cy="914400"/>
+          </a:xfrm>
+          <a:prstGeom prst="rect">
+            <a:avLst/>
+          </a:prstGeom>
+          <a:solidFill>
+            <a:srgbClr val="F2F6FB"/>
+          </a:solidFill>
+          <a:ln w="9525">
+            <a:solidFill>
+              <a:srgbClr val="D5DEE9"/>
+            </a:solidFill>
+            <a:prstDash val="solid"/>
+          </a:ln>
+        </p:spPr>
+      </p:sp>
+      <p:sp>
+        <p:nvSpPr>
+          <p:cNvPr id="11" name="Text 9"/>
+          <p:cNvSpPr/>
+          <p:nvPr/>
+        </p:nvSpPr>
+        <p:spPr>
+          <a:xfrm>
+            <a:off x="640080" y="3429000"/>
+            <a:ext cx="10972800" cy="320040"/>
+          </a:xfrm>
+          <a:prstGeom prst="rect">
+            <a:avLst/>
+          </a:prstGeom>
+          <a:noFill/>
+          <a:ln/>
+        </p:spPr>
+        <p:txBody>
+          <a:bodyPr wrap="square" lIns="0" tIns="0" rIns="0" bIns="0" rtlCol="0" anchor="ctr"/>
+          <a:lstStyle/>
+          <a:p>
+            <a:pPr indent="0" marL="0">
+              <a:buNone/>
+            </a:pPr>
+            <a:r>
+              <a:rPr lang="en-US" sz="1500" b="1" dirty="0">
+                <a:solidFill>
+                  <a:srgbClr val="1F6FEB"/>
+                </a:solidFill>
+                <a:latin typeface="Calibri" pitchFamily="34" charset="0"/>
+                <a:ea typeface="Calibri" pitchFamily="34" charset="-122"/>
+                <a:cs typeface="Calibri" pitchFamily="34" charset="-120"/>
+              </a:rPr>
+              <a:t>Did Smart-RUDP win?</a:t>
+            </a:r>
+            <a:endParaRPr lang="en-US" sz="1500" dirty="0"/>
+          </a:p>
+        </p:txBody>
+      </p:sp>
+      <p:sp>
+        <p:nvSpPr>
+          <p:cNvPr id="12" name="Text 10"/>
+          <p:cNvSpPr/>
+          <p:nvPr/>
+        </p:nvSpPr>
+        <p:spPr>
+          <a:xfrm>
+            <a:off x="640080" y="3749040"/>
+            <a:ext cx="10972800" cy="530352"/>
+          </a:xfrm>
+          <a:prstGeom prst="rect">
+            <a:avLst/>
+          </a:prstGeom>
+          <a:noFill/>
+          <a:ln/>
+        </p:spPr>
+        <p:txBody>
+          <a:bodyPr wrap="square" lIns="0" tIns="0" rIns="0" bIns="0" rtlCol="0" anchor="t"/>
+          <a:lstStyle/>
+          <a:p>
+            <a:pPr indent="0" marL="0">
+              <a:buNone/>
+            </a:pPr>
+            <a:r>
+              <a:rPr lang="en-US" sz="1350" dirty="0">
+                <a:solidFill>
+                  <a:srgbClr val="1B2430"/>
+                </a:solidFill>
+                <a:latin typeface="Calibri" pitchFamily="34" charset="0"/>
+                <a:ea typeface="Calibri" pitchFamily="34" charset="-122"/>
+                <a:cs typeface="Calibri" pitchFamily="34" charset="-120"/>
+              </a:rPr>
+              <a:t>Yes, in the final C transport against tuned baselines: 15 to 52 percent less time than tuned AIMD on four ordinary paths (real clock, real sockets and 100 random held-out paths agree), a tie on the 10 percent loss path. Against a simplified BBR it wins on the satellite-like and fast paths and loses on the 2 percent lossy path. The first tabular agent did not beat AIMD, and we say so.</a:t>
+            </a:r>
+            <a:endParaRPr lang="en-US" sz="1350" dirty="0"/>
+          </a:p>
+        </p:txBody>
+      </p:sp>
+      <p:sp>
+        <p:nvSpPr>
+          <p:cNvPr id="13" name="Shape 11"/>
+          <p:cNvSpPr/>
+          <p:nvPr/>
+        </p:nvSpPr>
+        <p:spPr>
+          <a:xfrm>
+            <a:off x="457200" y="4389120"/>
+            <a:ext cx="11274552" cy="914400"/>
+          </a:xfrm>
+          <a:prstGeom prst="rect">
+            <a:avLst/>
+          </a:prstGeom>
+          <a:solidFill>
+            <a:srgbClr val="F2F6FB"/>
+          </a:solidFill>
+          <a:ln w="9525">
+            <a:solidFill>
+              <a:srgbClr val="D5DEE9"/>
+            </a:solidFill>
+            <a:prstDash val="solid"/>
+          </a:ln>
+        </p:spPr>
+      </p:sp>
+      <p:sp>
+        <p:nvSpPr>
+          <p:cNvPr id="14" name="Text 12"/>
+          <p:cNvSpPr/>
+          <p:nvPr/>
+        </p:nvSpPr>
+        <p:spPr>
+          <a:xfrm>
+            <a:off x="640080" y="4434840"/>
+            <a:ext cx="10972800" cy="320040"/>
+          </a:xfrm>
+          <a:prstGeom prst="rect">
+            <a:avLst/>
+          </a:prstGeom>
+          <a:noFill/>
+          <a:ln/>
+        </p:spPr>
+        <p:txBody>
+          <a:bodyPr wrap="square" lIns="0" tIns="0" rIns="0" bIns="0" rtlCol="0" anchor="ctr"/>
+          <a:lstStyle/>
+          <a:p>
+            <a:pPr indent="0" marL="0">
+              <a:buNone/>
+            </a:pPr>
+            <a:r>
+              <a:rPr lang="en-US" sz="1500" b="1" dirty="0">
+                <a:solidFill>
+                  <a:srgbClr val="1F6FEB"/>
+                </a:solidFill>
+                <a:latin typeface="Calibri" pitchFamily="34" charset="0"/>
+                <a:ea typeface="Calibri" pitchFamily="34" charset="-122"/>
+                <a:cs typeface="Calibri" pitchFamily="34" charset="-120"/>
+              </a:rPr>
+              <a:t>Why Go-Back-N?</a:t>
+            </a:r>
+            <a:endParaRPr lang="en-US" sz="1500" dirty="0"/>
+          </a:p>
+        </p:txBody>
+      </p:sp>
+      <p:sp>
+        <p:nvSpPr>
+          <p:cNvPr id="15" name="Text 13"/>
+          <p:cNvSpPr/>
+          <p:nvPr/>
+        </p:nvSpPr>
+        <p:spPr>
+          <a:xfrm>
+            <a:off x="640080" y="4754880"/>
+            <a:ext cx="10972800" cy="530352"/>
+          </a:xfrm>
+          <a:prstGeom prst="rect">
+            <a:avLst/>
+          </a:prstGeom>
+          <a:noFill/>
+          <a:ln/>
+        </p:spPr>
+        <p:txBody>
+          <a:bodyPr wrap="square" lIns="0" tIns="0" rIns="0" bIns="0" rtlCol="0" anchor="t"/>
+          <a:lstStyle/>
+          <a:p>
+            <a:pPr indent="0" marL="0">
+              <a:buNone/>
+            </a:pPr>
+            <a:r>
+              <a:rPr lang="en-US" sz="1350" dirty="0">
+                <a:solidFill>
+                  <a:srgbClr val="1B2430"/>
+                </a:solidFill>
+                <a:latin typeface="Calibri" pitchFamily="34" charset="0"/>
+                <a:ea typeface="Calibri" pitchFamily="34" charset="-122"/>
+                <a:cs typeface="Calibri" pitchFamily="34" charset="-120"/>
+              </a:rPr>
+              <a:t>We started with it because it is simple to build and explain, then replaced it as the default with Selective Repeat: the receiver buffers out-of-order packets and reports them in an ACK bitmap, and the sender resends only what is missing. Go-Back-N stays behind a flag for comparison.</a:t>
+            </a:r>
+            <a:endParaRPr lang="en-US" sz="1350" dirty="0"/>
+          </a:p>
+        </p:txBody>
+      </p:sp>
+      <p:sp>
+        <p:nvSpPr>
+          <p:cNvPr id="16" name="Shape 14"/>
+          <p:cNvSpPr/>
+          <p:nvPr/>
+        </p:nvSpPr>
+        <p:spPr>
+          <a:xfrm>
+            <a:off x="457200" y="5394960"/>
+            <a:ext cx="11274552" cy="914400"/>
+          </a:xfrm>
+          <a:prstGeom prst="rect">
+            <a:avLst/>
+          </a:prstGeom>
+          <a:solidFill>
+            <a:srgbClr val="F2F6FB"/>
+          </a:solidFill>
+          <a:ln w="9525">
+            <a:solidFill>
+              <a:srgbClr val="D5DEE9"/>
+            </a:solidFill>
+            <a:prstDash val="solid"/>
+          </a:ln>
+        </p:spPr>
+      </p:sp>
+      <p:sp>
+        <p:nvSpPr>
+          <p:cNvPr id="17" name="Text 15"/>
+          <p:cNvSpPr/>
+          <p:nvPr/>
+        </p:nvSpPr>
+        <p:spPr>
+          <a:xfrm>
+            <a:off x="640080" y="5440680"/>
+            <a:ext cx="10972800" cy="320040"/>
+          </a:xfrm>
+          <a:prstGeom prst="rect">
+            <a:avLst/>
+          </a:prstGeom>
+          <a:noFill/>
+          <a:ln/>
+        </p:spPr>
+        <p:txBody>
+          <a:bodyPr wrap="square" lIns="0" tIns="0" rIns="0" bIns="0" rtlCol="0" anchor="ctr"/>
+          <a:lstStyle/>
+          <a:p>
+            <a:pPr indent="0" marL="0">
+              <a:buNone/>
+            </a:pPr>
+            <a:r>
+              <a:rPr lang="en-US" sz="1500" b="1" dirty="0">
+                <a:solidFill>
+                  <a:srgbClr val="1F6FEB"/>
+                </a:solidFill>
+                <a:latin typeface="Calibri" pitchFamily="34" charset="0"/>
+                <a:ea typeface="Calibri" pitchFamily="34" charset="-122"/>
+                <a:cs typeface="Calibri" pitchFamily="34" charset="-120"/>
+              </a:rPr>
+              <a:t>Was it tested between machines?</a:t>
+            </a:r>
+            <a:endParaRPr lang="en-US" sz="1500" dirty="0"/>
+          </a:p>
+        </p:txBody>
+      </p:sp>
+      <p:sp>
+        <p:nvSpPr>
+          <p:cNvPr id="18" name="Text 16"/>
+          <p:cNvSpPr/>
+          <p:nvPr/>
+        </p:nvSpPr>
+        <p:spPr>
+          <a:xfrm>
+            <a:off x="640080" y="5760720"/>
+            <a:ext cx="10972800" cy="530352"/>
+          </a:xfrm>
+          <a:prstGeom prst="rect">
+            <a:avLst/>
+          </a:prstGeom>
+          <a:noFill/>
+          <a:ln/>
+        </p:spPr>
+        <p:txBody>
+          <a:bodyPr wrap="square" lIns="0" tIns="0" rIns="0" bIns="0" rtlCol="0" anchor="t"/>
+          <a:lstStyle/>
+          <a:p>
+            <a:pPr indent="0" marL="0">
+              <a:buNone/>
+            </a:pPr>
+            <a:r>
+              <a:rPr lang="en-US" sz="1350" dirty="0">
+                <a:solidFill>
+                  <a:srgbClr val="1B2430"/>
+                </a:solidFill>
+                <a:latin typeface="Calibri" pitchFamily="34" charset="0"/>
+                <a:ea typeface="Calibri" pitchFamily="34" charset="-122"/>
+                <a:cs typeface="Calibri" pitchFamily="34" charset="-120"/>
+              </a:rPr>
+              <a:t>Yes. Delay, loss and jitter are emulated in our client, in a separate proxy on real UDP sockets, and in virtual time; these agree with each other. We also ran it once on the Linux kernel with tc netem on one laptop: the agent beat tuned AIMD there, but kernel TCP was 1.5 to 1.7 times faster than us. We also made one run between two laptops on different networks over a Tailscale relay: RUDP delivered every transfer that finished, but the path drifted and four of twenty runs timed out, so we do not rank the policies from it; kernel TCP was 2 to 6 times faster on the clean repetitions.</a:t>
+            </a:r>
+            <a:endParaRPr lang="en-US" sz="1350" dirty="0"/>
+          </a:p>
+        </p:txBody>
+      </p:sp>
+    </p:spTree>
+  </p:cSld>
+  <p:clrMapOvr>
+    <a:masterClrMapping/>
+  </p:clrMapOvr>
+</p:sld>
+</file>
+
+<file path=ppt/slides/slide43.xml><?xml version="1.0" encoding="utf-8"?>
+<p:sld xmlns:a="http://schemas.openxmlformats.org/drawingml/2006/main" xmlns:r="http://schemas.openxmlformats.org/officeDocument/2006/relationships" xmlns:p="http://schemas.openxmlformats.org/presentationml/2006/main">
+  <p:cSld name="Slide 43">
+    <p:bg>
+      <p:bgPr>
+        <a:solidFill>
+          <a:srgbClr val="FFFFFF"/>
+        </a:solidFill>
+      </p:bgPr>
+    </p:bg>
+    <p:spTree>
+      <p:nvGrpSpPr>
+        <p:cNvPr id="1" name=""/>
+        <p:cNvGrpSpPr/>
+        <p:nvPr/>
+      </p:nvGrpSpPr>
+      <p:grpSpPr>
+        <a:xfrm>
+          <a:off x="0" y="0"/>
+          <a:ext cx="0" cy="0"/>
+          <a:chOff x="0" y="0"/>
+          <a:chExt cx="0" cy="0"/>
+        </a:xfrm>
+      </p:grpSpPr>
+      <p:sp>
+        <p:nvSpPr>
+          <p:cNvPr id="2" name="Text 0"/>
+          <p:cNvSpPr/>
+          <p:nvPr/>
+        </p:nvSpPr>
+        <p:spPr>
+          <a:xfrm>
+            <a:off x="457200" y="274320"/>
+            <a:ext cx="9601200" cy="548640"/>
+          </a:xfrm>
+          <a:prstGeom prst="rect">
+            <a:avLst/>
+          </a:prstGeom>
+          <a:noFill/>
+          <a:ln/>
+        </p:spPr>
+        <p:txBody>
+          <a:bodyPr wrap="square" lIns="0" tIns="0" rIns="0" bIns="0" rtlCol="0" anchor="ctr"/>
+          <a:lstStyle/>
+          <a:p>
+            <a:pPr indent="0" marL="0">
+              <a:buNone/>
+            </a:pPr>
+            <a:r>
+              <a:rPr lang="en-US" sz="2600" b="1" dirty="0">
+                <a:solidFill>
+                  <a:srgbClr val="1B2430"/>
+                </a:solidFill>
+                <a:latin typeface="Calibri" pitchFamily="34" charset="0"/>
+                <a:ea typeface="Calibri" pitchFamily="34" charset="-122"/>
+                <a:cs typeface="Calibri" pitchFamily="34" charset="-120"/>
+              </a:rPr>
+              <a:t>Hard questions and short answers (2 of 3)</a:t>
+            </a:r>
+            <a:endParaRPr lang="en-US" sz="2600" dirty="0"/>
+          </a:p>
+        </p:txBody>
+      </p:sp>
+      <p:sp>
+        <p:nvSpPr>
+          <p:cNvPr id="3" name="Shape 1"/>
+          <p:cNvSpPr/>
+          <p:nvPr/>
+        </p:nvSpPr>
+        <p:spPr>
+          <a:xfrm>
+            <a:off x="457200" y="1143000"/>
+            <a:ext cx="11274552" cy="36576"/>
+          </a:xfrm>
+          <a:prstGeom prst="rect">
+            <a:avLst/>
+          </a:prstGeom>
+          <a:solidFill>
+            <a:srgbClr val="1F6FEB"/>
+          </a:solidFill>
+          <a:ln w="12700">
+            <a:solidFill>
+              <a:srgbClr val="1F6FEB"/>
+            </a:solidFill>
+            <a:prstDash val="solid"/>
+          </a:ln>
+        </p:spPr>
+      </p:sp>
+      <p:sp>
+        <p:nvSpPr>
+          <p:cNvPr id="4" name="Shape 2"/>
+          <p:cNvSpPr/>
+          <p:nvPr/>
+        </p:nvSpPr>
+        <p:spPr>
+          <a:xfrm>
+            <a:off x="457200" y="1371600"/>
+            <a:ext cx="11274552" cy="914400"/>
+          </a:xfrm>
+          <a:prstGeom prst="rect">
+            <a:avLst/>
+          </a:prstGeom>
+          <a:solidFill>
+            <a:srgbClr val="F2F6FB"/>
+          </a:solidFill>
+          <a:ln w="9525">
+            <a:solidFill>
+              <a:srgbClr val="D5DEE9"/>
+            </a:solidFill>
+            <a:prstDash val="solid"/>
+          </a:ln>
+        </p:spPr>
+      </p:sp>
+      <p:sp>
+        <p:nvSpPr>
+          <p:cNvPr id="5" name="Text 3"/>
+          <p:cNvSpPr/>
+          <p:nvPr/>
+        </p:nvSpPr>
+        <p:spPr>
+          <a:xfrm>
+            <a:off x="640080" y="1417320"/>
+            <a:ext cx="10972800" cy="320040"/>
+          </a:xfrm>
+          <a:prstGeom prst="rect">
+            <a:avLst/>
+          </a:prstGeom>
+          <a:noFill/>
+          <a:ln/>
+        </p:spPr>
+        <p:txBody>
+          <a:bodyPr wrap="square" lIns="0" tIns="0" rIns="0" bIns="0" rtlCol="0" anchor="ctr"/>
+          <a:lstStyle/>
+          <a:p>
+            <a:pPr indent="0" marL="0">
+              <a:buNone/>
+            </a:pPr>
+            <a:r>
+              <a:rPr lang="en-US" sz="1500" b="1" dirty="0">
+                <a:solidFill>
+                  <a:srgbClr val="1F6FEB"/>
+                </a:solidFill>
+                <a:latin typeface="Calibri" pitchFamily="34" charset="0"/>
+                <a:ea typeface="Calibri" pitchFamily="34" charset="-122"/>
+                <a:cs typeface="Calibri" pitchFamily="34" charset="-120"/>
+              </a:rPr>
+              <a:t>What does Packet Tracer prove?</a:t>
+            </a:r>
+            <a:endParaRPr lang="en-US" sz="1500" dirty="0"/>
+          </a:p>
+        </p:txBody>
+      </p:sp>
+      <p:sp>
+        <p:nvSpPr>
+          <p:cNvPr id="6" name="Text 4"/>
+          <p:cNvSpPr/>
+          <p:nvPr/>
+        </p:nvSpPr>
+        <p:spPr>
+          <a:xfrm>
+            <a:off x="640080" y="1737360"/>
+            <a:ext cx="10972800" cy="530352"/>
+          </a:xfrm>
+          <a:prstGeom prst="rect">
+            <a:avLst/>
+          </a:prstGeom>
+          <a:noFill/>
+          <a:ln/>
+        </p:spPr>
+        <p:txBody>
+          <a:bodyPr wrap="square" lIns="0" tIns="0" rIns="0" bIns="0" rtlCol="0" anchor="t"/>
+          <a:lstStyle/>
+          <a:p>
+            <a:pPr indent="0" marL="0">
+              <a:buNone/>
+            </a:pPr>
+            <a:r>
+              <a:rPr lang="en-US" sz="1350" dirty="0">
+                <a:solidFill>
+                  <a:srgbClr val="1B2430"/>
+                </a:solidFill>
+                <a:latin typeface="Calibri" pitchFamily="34" charset="0"/>
+                <a:ea typeface="Calibri" pitchFamily="34" charset="-122"/>
+                <a:cs typeface="Calibri" pitchFamily="34" charset="-120"/>
+              </a:rPr>
+              <a:t>The network design: OSPF, VLANs, ACL, 70/71 failover. The protocol is validated separately with emulation and Wireshark.</a:t>
+            </a:r>
+            <a:endParaRPr lang="en-US" sz="1350" dirty="0"/>
+          </a:p>
+        </p:txBody>
+      </p:sp>
+      <p:sp>
+        <p:nvSpPr>
+          <p:cNvPr id="7" name="Shape 5"/>
+          <p:cNvSpPr/>
+          <p:nvPr/>
+        </p:nvSpPr>
+        <p:spPr>
+          <a:xfrm>
+            <a:off x="457200" y="2377440"/>
+            <a:ext cx="11274552" cy="914400"/>
+          </a:xfrm>
+          <a:prstGeom prst="rect">
+            <a:avLst/>
+          </a:prstGeom>
+          <a:solidFill>
+            <a:srgbClr val="F2F6FB"/>
+          </a:solidFill>
+          <a:ln w="9525">
+            <a:solidFill>
+              <a:srgbClr val="D5DEE9"/>
+            </a:solidFill>
+            <a:prstDash val="solid"/>
+          </a:ln>
+        </p:spPr>
+      </p:sp>
+      <p:sp>
+        <p:nvSpPr>
+          <p:cNvPr id="8" name="Text 6"/>
+          <p:cNvSpPr/>
+          <p:nvPr/>
+        </p:nvSpPr>
+        <p:spPr>
+          <a:xfrm>
+            <a:off x="640080" y="2423160"/>
+            <a:ext cx="10972800" cy="320040"/>
+          </a:xfrm>
+          <a:prstGeom prst="rect">
+            <a:avLst/>
+          </a:prstGeom>
+          <a:noFill/>
+          <a:ln/>
+        </p:spPr>
+        <p:txBody>
+          <a:bodyPr wrap="square" lIns="0" tIns="0" rIns="0" bIns="0" rtlCol="0" anchor="ctr"/>
+          <a:lstStyle/>
+          <a:p>
+            <a:pPr indent="0" marL="0">
+              <a:buNone/>
+            </a:pPr>
+            <a:r>
+              <a:rPr lang="en-US" sz="1500" b="1" dirty="0">
+                <a:solidFill>
+                  <a:srgbClr val="1F6FEB"/>
+                </a:solidFill>
+                <a:latin typeface="Calibri" pitchFamily="34" charset="0"/>
+                <a:ea typeface="Calibri" pitchFamily="34" charset="-122"/>
+                <a:cs typeface="Calibri" pitchFamily="34" charset="-120"/>
+              </a:rPr>
+              <a:t>Peer disappears?</a:t>
+            </a:r>
+            <a:endParaRPr lang="en-US" sz="1500" dirty="0"/>
+          </a:p>
+        </p:txBody>
+      </p:sp>
+      <p:sp>
+        <p:nvSpPr>
+          <p:cNvPr id="9" name="Text 7"/>
+          <p:cNvSpPr/>
+          <p:nvPr/>
+        </p:nvSpPr>
+        <p:spPr>
+          <a:xfrm>
+            <a:off x="640080" y="2743200"/>
+            <a:ext cx="10972800" cy="530352"/>
+          </a:xfrm>
+          <a:prstGeom prst="rect">
+            <a:avLst/>
+          </a:prstGeom>
+          <a:noFill/>
+          <a:ln/>
+        </p:spPr>
+        <p:txBody>
+          <a:bodyPr wrap="square" lIns="0" tIns="0" rIns="0" bIns="0" rtlCol="0" anchor="t"/>
+          <a:lstStyle/>
+          <a:p>
+            <a:pPr indent="0" marL="0">
+              <a:buNone/>
+            </a:pPr>
+            <a:r>
+              <a:rPr lang="en-US" sz="1350" dirty="0">
+                <a:solidFill>
+                  <a:srgbClr val="1B2430"/>
+                </a:solidFill>
+                <a:latin typeface="Calibri" pitchFamily="34" charset="0"/>
+                <a:ea typeface="Calibri" pitchFamily="34" charset="-122"/>
+                <a:cs typeface="Calibri" pitchFamily="34" charset="-120"/>
+              </a:rPr>
+              <a:t>Sender keeps retransmitting on timeout. A connection abort after repeated timeouts is not built; it is the fix we would add.</a:t>
+            </a:r>
+            <a:endParaRPr lang="en-US" sz="1350" dirty="0"/>
+          </a:p>
+        </p:txBody>
+      </p:sp>
+      <p:sp>
+        <p:nvSpPr>
+          <p:cNvPr id="10" name="Shape 8"/>
+          <p:cNvSpPr/>
+          <p:nvPr/>
+        </p:nvSpPr>
+        <p:spPr>
+          <a:xfrm>
+            <a:off x="457200" y="3383280"/>
+            <a:ext cx="11274552" cy="914400"/>
+          </a:xfrm>
+          <a:prstGeom prst="rect">
+            <a:avLst/>
+          </a:prstGeom>
+          <a:solidFill>
+            <a:srgbClr val="F2F6FB"/>
+          </a:solidFill>
+          <a:ln w="9525">
+            <a:solidFill>
+              <a:srgbClr val="D5DEE9"/>
+            </a:solidFill>
+            <a:prstDash val="solid"/>
+          </a:ln>
+        </p:spPr>
+      </p:sp>
+      <p:sp>
+        <p:nvSpPr>
+          <p:cNvPr id="11" name="Text 9"/>
+          <p:cNvSpPr/>
+          <p:nvPr/>
+        </p:nvSpPr>
+        <p:spPr>
+          <a:xfrm>
+            <a:off x="640080" y="3429000"/>
+            <a:ext cx="10972800" cy="320040"/>
+          </a:xfrm>
+          <a:prstGeom prst="rect">
+            <a:avLst/>
+          </a:prstGeom>
+          <a:noFill/>
+          <a:ln/>
+        </p:spPr>
+        <p:txBody>
+          <a:bodyPr wrap="square" lIns="0" tIns="0" rIns="0" bIns="0" rtlCol="0" anchor="ctr"/>
+          <a:lstStyle/>
+          <a:p>
+            <a:pPr indent="0" marL="0">
+              <a:buNone/>
+            </a:pPr>
+            <a:r>
+              <a:rPr lang="en-US" sz="1500" b="1" dirty="0">
+                <a:solidFill>
+                  <a:srgbClr val="1F6FEB"/>
+                </a:solidFill>
+                <a:latin typeface="Calibri" pitchFamily="34" charset="0"/>
+                <a:ea typeface="Calibri" pitchFamily="34" charset="-122"/>
+                <a:cs typeface="Calibri" pitchFamily="34" charset="-120"/>
+              </a:rPr>
+              <a:t>Does the checksum catch errors?</a:t>
+            </a:r>
+            <a:endParaRPr lang="en-US" sz="1500" dirty="0"/>
+          </a:p>
+        </p:txBody>
+      </p:sp>
+      <p:sp>
+        <p:nvSpPr>
+          <p:cNvPr id="12" name="Text 10"/>
+          <p:cNvSpPr/>
+          <p:nvPr/>
+        </p:nvSpPr>
+        <p:spPr>
+          <a:xfrm>
+            <a:off x="640080" y="3749040"/>
+            <a:ext cx="10972800" cy="530352"/>
+          </a:xfrm>
+          <a:prstGeom prst="rect">
+            <a:avLst/>
+          </a:prstGeom>
+          <a:noFill/>
+          <a:ln/>
+        </p:spPr>
+        <p:txBody>
+          <a:bodyPr wrap="square" lIns="0" tIns="0" rIns="0" bIns="0" rtlCol="0" anchor="t"/>
+          <a:lstStyle/>
+          <a:p>
+            <a:pPr indent="0" marL="0">
+              <a:buNone/>
+            </a:pPr>
+            <a:r>
+              <a:rPr lang="en-US" sz="1350" dirty="0">
+                <a:solidFill>
+                  <a:srgbClr val="1B2430"/>
+                </a:solidFill>
+                <a:latin typeface="Calibri" pitchFamily="34" charset="0"/>
+                <a:ea typeface="Calibri" pitchFamily="34" charset="-122"/>
+                <a:cs typeface="Calibri" pitchFamily="34" charset="-120"/>
+              </a:rPr>
+              <a:t>It is CRC-16/CCITT now. The first version was a byte sum and a fuzzer showed 2 percent of corrupted packets got through; with CRC-16 none of 333,000 did. It cannot catch every error pattern, as no 16-bit check can.</a:t>
+            </a:r>
+            <a:endParaRPr lang="en-US" sz="1350" dirty="0"/>
+          </a:p>
+        </p:txBody>
+      </p:sp>
+      <p:sp>
+        <p:nvSpPr>
+          <p:cNvPr id="13" name="Shape 11"/>
+          <p:cNvSpPr/>
+          <p:nvPr/>
+        </p:nvSpPr>
+        <p:spPr>
+          <a:xfrm>
+            <a:off x="457200" y="4389120"/>
+            <a:ext cx="11274552" cy="914400"/>
+          </a:xfrm>
+          <a:prstGeom prst="rect">
+            <a:avLst/>
+          </a:prstGeom>
+          <a:solidFill>
+            <a:srgbClr val="F2F6FB"/>
+          </a:solidFill>
+          <a:ln w="9525">
+            <a:solidFill>
+              <a:srgbClr val="D5DEE9"/>
+            </a:solidFill>
+            <a:prstDash val="solid"/>
+          </a:ln>
+        </p:spPr>
+      </p:sp>
+      <p:sp>
+        <p:nvSpPr>
+          <p:cNvPr id="14" name="Text 12"/>
+          <p:cNvSpPr/>
+          <p:nvPr/>
+        </p:nvSpPr>
+        <p:spPr>
+          <a:xfrm>
+            <a:off x="640080" y="4434840"/>
+            <a:ext cx="10972800" cy="320040"/>
+          </a:xfrm>
+          <a:prstGeom prst="rect">
+            <a:avLst/>
+          </a:prstGeom>
+          <a:noFill/>
+          <a:ln/>
+        </p:spPr>
+        <p:txBody>
+          <a:bodyPr wrap="square" lIns="0" tIns="0" rIns="0" bIns="0" rtlCol="0" anchor="ctr"/>
+          <a:lstStyle/>
+          <a:p>
+            <a:pPr indent="0" marL="0">
+              <a:buNone/>
+            </a:pPr>
+            <a:r>
+              <a:rPr lang="en-US" sz="1500" b="1" dirty="0">
+                <a:solidFill>
+                  <a:srgbClr val="1F6FEB"/>
+                </a:solidFill>
+                <a:latin typeface="Calibri" pitchFamily="34" charset="0"/>
+                <a:ea typeface="Calibri" pitchFamily="34" charset="-122"/>
+                <a:cs typeface="Calibri" pitchFamily="34" charset="-120"/>
+              </a:rPr>
+              <a:t>Why no handshake in the exported trace?</a:t>
+            </a:r>
+            <a:endParaRPr lang="en-US" sz="1500" dirty="0"/>
+          </a:p>
+        </p:txBody>
+      </p:sp>
+      <p:sp>
+        <p:nvSpPr>
+          <p:cNvPr id="15" name="Text 13"/>
+          <p:cNvSpPr/>
+          <p:nvPr/>
+        </p:nvSpPr>
+        <p:spPr>
+          <a:xfrm>
+            <a:off x="640080" y="4754880"/>
+            <a:ext cx="10972800" cy="530352"/>
+          </a:xfrm>
+          <a:prstGeom prst="rect">
+            <a:avLst/>
+          </a:prstGeom>
+          <a:noFill/>
+          <a:ln/>
+        </p:spPr>
+        <p:txBody>
+          <a:bodyPr wrap="square" lIns="0" tIns="0" rIns="0" bIns="0" rtlCol="0" anchor="t"/>
+          <a:lstStyle/>
+          <a:p>
+            <a:pPr indent="0" marL="0">
+              <a:buNone/>
+            </a:pPr>
+            <a:r>
+              <a:rPr lang="en-US" sz="1350" dirty="0">
+                <a:solidFill>
+                  <a:srgbClr val="1B2430"/>
+                </a:solidFill>
+                <a:latin typeface="Calibri" pitchFamily="34" charset="0"/>
+                <a:ea typeface="Calibri" pitchFamily="34" charset="-122"/>
+                <a:cs typeface="Calibri" pitchFamily="34" charset="-120"/>
+              </a:rPr>
+              <a:t>The export builds synthetic packets. The real tshark capture shows SYN, SYN-ACK, ACK.</a:t>
+            </a:r>
+            <a:endParaRPr lang="en-US" sz="1350" dirty="0"/>
+          </a:p>
+        </p:txBody>
+      </p:sp>
+      <p:sp>
+        <p:nvSpPr>
+          <p:cNvPr id="16" name="Shape 14"/>
+          <p:cNvSpPr/>
+          <p:nvPr/>
+        </p:nvSpPr>
+        <p:spPr>
+          <a:xfrm>
+            <a:off x="457200" y="5394960"/>
+            <a:ext cx="11274552" cy="914400"/>
+          </a:xfrm>
+          <a:prstGeom prst="rect">
+            <a:avLst/>
+          </a:prstGeom>
+          <a:solidFill>
+            <a:srgbClr val="F2F6FB"/>
+          </a:solidFill>
+          <a:ln w="9525">
+            <a:solidFill>
+              <a:srgbClr val="D5DEE9"/>
+            </a:solidFill>
+            <a:prstDash val="solid"/>
+          </a:ln>
+        </p:spPr>
+      </p:sp>
+      <p:sp>
+        <p:nvSpPr>
+          <p:cNvPr id="17" name="Text 15"/>
+          <p:cNvSpPr/>
+          <p:nvPr/>
+        </p:nvSpPr>
+        <p:spPr>
+          <a:xfrm>
+            <a:off x="640080" y="5440680"/>
+            <a:ext cx="10972800" cy="320040"/>
+          </a:xfrm>
+          <a:prstGeom prst="rect">
+            <a:avLst/>
+          </a:prstGeom>
+          <a:noFill/>
+          <a:ln/>
+        </p:spPr>
+        <p:txBody>
+          <a:bodyPr wrap="square" lIns="0" tIns="0" rIns="0" bIns="0" rtlCol="0" anchor="ctr"/>
+          <a:lstStyle/>
+          <a:p>
+            <a:pPr indent="0" marL="0">
+              <a:buNone/>
+            </a:pPr>
+            <a:r>
+              <a:rPr lang="en-US" sz="1500" b="1" dirty="0">
+                <a:solidFill>
+                  <a:srgbClr val="1F6FEB"/>
+                </a:solidFill>
+                <a:latin typeface="Calibri" pitchFamily="34" charset="0"/>
+                <a:ea typeface="Calibri" pitchFamily="34" charset="-122"/>
+                <a:cs typeface="Calibri" pitchFamily="34" charset="-120"/>
+              </a:rPr>
+              <a:t>Is the baseline fair?</a:t>
+            </a:r>
+            <a:endParaRPr lang="en-US" sz="1500" dirty="0"/>
+          </a:p>
+        </p:txBody>
+      </p:sp>
+      <p:sp>
+        <p:nvSpPr>
+          <p:cNvPr id="18" name="Text 16"/>
+          <p:cNvSpPr/>
+          <p:nvPr/>
+        </p:nvSpPr>
+        <p:spPr>
+          <a:xfrm>
+            <a:off x="640080" y="5760720"/>
+            <a:ext cx="10972800" cy="530352"/>
+          </a:xfrm>
+          <a:prstGeom prst="rect">
+            <a:avLst/>
+          </a:prstGeom>
+          <a:noFill/>
+          <a:ln/>
+        </p:spPr>
+        <p:txBody>
+          <a:bodyPr wrap="square" lIns="0" tIns="0" rIns="0" bIns="0" rtlCol="0" anchor="t"/>
+          <a:lstStyle/>
+          <a:p>
+            <a:pPr indent="0" marL="0">
+              <a:buNone/>
+            </a:pPr>
+            <a:r>
+              <a:rPr lang="en-US" sz="1350" dirty="0">
+                <a:solidFill>
+                  <a:srgbClr val="1B2430"/>
+                </a:solidFill>
+                <a:latin typeface="Calibri" pitchFamily="34" charset="0"/>
+                <a:ea typeface="Calibri" pitchFamily="34" charset="-122"/>
+                <a:cs typeface="Calibri" pitchFamily="34" charset="-120"/>
+              </a:rPr>
+              <a:t>We tuned it: window cap 128 and a high start threshold, plus the same retransmission-timer floor for every policy. We also compare against tuned CUBIC. Tuned AIMD improved a lot, and the agent is still ahead on four paths.</a:t>
+            </a:r>
+            <a:endParaRPr lang="en-US" sz="1350" dirty="0"/>
+          </a:p>
+        </p:txBody>
+      </p:sp>
+    </p:spTree>
+  </p:cSld>
+  <p:clrMapOvr>
+    <a:masterClrMapping/>
+  </p:clrMapOvr>
+</p:sld>
+</file>
+
+<file path=ppt/slides/slide44.xml><?xml version="1.0" encoding="utf-8"?>
+<p:sld xmlns:a="http://schemas.openxmlformats.org/drawingml/2006/main" xmlns:r="http://schemas.openxmlformats.org/officeDocument/2006/relationships" xmlns:p="http://schemas.openxmlformats.org/presentationml/2006/main">
+  <p:cSld name="Slide 44">
     <p:bg>
       <p:bgPr>
         <a:solidFill>

</xml_diff>